<commit_message>
docs: mark both decks' text as Japanese
Exported outside PowerPoint, text whose theme leaves the East Asian
face empty and whose runs are not marked Japanese can fall back to a
Chinese face. Every run, paragraph end and default run property in
both files is now ja-JP, and each theme names a Japanese face: Yu
Gothic throughout the poster, Yu Gothic Light and Yu Gothic for the
deck's headings and body. The poster's properties still named
python-pptx's sample author and 2013; they now name the author and
the day. The deck drops the 10/23 deck's co-authoring change log and
revision list, a record of that deck's editing, and both files
rebuild their extended properties from the slides they hold.
</commit_message>
<xml_diff>
--- a/presentations/20261116_PCSJ-IMPS2026_ポスター初案.pptx
+++ b/presentations/20261116_PCSJ-IMPS2026_ポスター初案.pptx
@@ -11,10 +11,10 @@
   <p:notesSz cx="6858000" cy="9144000"/>
   <p:defaultTextStyle>
     <a:defPPr>
-      <a:defRPr lang="en-US"/>
+      <a:defRPr lang="ja-JP"/>
     </a:defPPr>
     <a:lvl1pPr marL="0" algn="l" defTabSz="457200" rtl="0" eaLnBrk="1" latinLnBrk="0" hangingPunct="1">
-      <a:defRPr sz="1800" kern="1200">
+      <a:defRPr sz="1800" kern="1200" lang="ja-JP">
         <a:solidFill>
           <a:schemeClr val="tx1"/>
         </a:solidFill>
@@ -24,7 +24,7 @@
       </a:defRPr>
     </a:lvl1pPr>
     <a:lvl2pPr marL="457200" algn="l" defTabSz="457200" rtl="0" eaLnBrk="1" latinLnBrk="0" hangingPunct="1">
-      <a:defRPr sz="1800" kern="1200">
+      <a:defRPr sz="1800" kern="1200" lang="ja-JP">
         <a:solidFill>
           <a:schemeClr val="tx1"/>
         </a:solidFill>
@@ -34,7 +34,7 @@
       </a:defRPr>
     </a:lvl2pPr>
     <a:lvl3pPr marL="914400" algn="l" defTabSz="457200" rtl="0" eaLnBrk="1" latinLnBrk="0" hangingPunct="1">
-      <a:defRPr sz="1800" kern="1200">
+      <a:defRPr sz="1800" kern="1200" lang="ja-JP">
         <a:solidFill>
           <a:schemeClr val="tx1"/>
         </a:solidFill>
@@ -44,7 +44,7 @@
       </a:defRPr>
     </a:lvl3pPr>
     <a:lvl4pPr marL="1371600" algn="l" defTabSz="457200" rtl="0" eaLnBrk="1" latinLnBrk="0" hangingPunct="1">
-      <a:defRPr sz="1800" kern="1200">
+      <a:defRPr sz="1800" kern="1200" lang="ja-JP">
         <a:solidFill>
           <a:schemeClr val="tx1"/>
         </a:solidFill>
@@ -54,7 +54,7 @@
       </a:defRPr>
     </a:lvl4pPr>
     <a:lvl5pPr marL="1828800" algn="l" defTabSz="457200" rtl="0" eaLnBrk="1" latinLnBrk="0" hangingPunct="1">
-      <a:defRPr sz="1800" kern="1200">
+      <a:defRPr sz="1800" kern="1200" lang="ja-JP">
         <a:solidFill>
           <a:schemeClr val="tx1"/>
         </a:solidFill>
@@ -64,7 +64,7 @@
       </a:defRPr>
     </a:lvl5pPr>
     <a:lvl6pPr marL="2286000" algn="l" defTabSz="457200" rtl="0" eaLnBrk="1" latinLnBrk="0" hangingPunct="1">
-      <a:defRPr sz="1800" kern="1200">
+      <a:defRPr sz="1800" kern="1200" lang="ja-JP">
         <a:solidFill>
           <a:schemeClr val="tx1"/>
         </a:solidFill>
@@ -74,7 +74,7 @@
       </a:defRPr>
     </a:lvl6pPr>
     <a:lvl7pPr marL="2743200" algn="l" defTabSz="457200" rtl="0" eaLnBrk="1" latinLnBrk="0" hangingPunct="1">
-      <a:defRPr sz="1800" kern="1200">
+      <a:defRPr sz="1800" kern="1200" lang="ja-JP">
         <a:solidFill>
           <a:schemeClr val="tx1"/>
         </a:solidFill>
@@ -84,7 +84,7 @@
       </a:defRPr>
     </a:lvl7pPr>
     <a:lvl8pPr marL="3200400" algn="l" defTabSz="457200" rtl="0" eaLnBrk="1" latinLnBrk="0" hangingPunct="1">
-      <a:defRPr sz="1800" kern="1200">
+      <a:defRPr sz="1800" kern="1200" lang="ja-JP">
         <a:solidFill>
           <a:schemeClr val="tx1"/>
         </a:solidFill>
@@ -94,7 +94,7 @@
       </a:defRPr>
     </a:lvl8pPr>
     <a:lvl9pPr marL="3657600" algn="l" defTabSz="457200" rtl="0" eaLnBrk="1" latinLnBrk="0" hangingPunct="1">
-      <a:defRPr sz="1800" kern="1200">
+      <a:defRPr sz="1800" kern="1200" lang="ja-JP">
         <a:solidFill>
           <a:schemeClr val="tx1"/>
         </a:solidFill>
@@ -201,7 +201,7 @@
             <a:lstStyle/>
             <a:p>
               <a:pPr>
-                <a:defRPr sz="2400">
+                <a:defRPr sz="2400" lang="ja-JP">
                   <a:latin typeface="游ゴシック"/>
                 </a:defRPr>
               </a:pPr>
@@ -242,7 +242,7 @@
           <a:lstStyle/>
           <a:p>
             <a:pPr>
-              <a:defRPr sz="2400"/>
+              <a:defRPr sz="2400" lang="ja-JP"/>
             </a:pPr>
           </a:p>
         </c:txPr>
@@ -283,7 +283,7 @@
           <a:lstStyle/>
           <a:p>
             <a:pPr>
-              <a:defRPr sz="2400">
+              <a:defRPr sz="2400" lang="ja-JP">
                 <a:solidFill>
                   <a:srgbClr val="595959"/>
                 </a:solidFill>
@@ -303,12 +303,12 @@
     <a:lstStyle/>
     <a:p>
       <a:pPr>
-        <a:defRPr sz="2400">
+        <a:defRPr sz="2400" lang="ja-JP">
           <a:latin typeface="游ゴシック"/>
           <a:ea typeface="游ゴシック"/>
         </a:defRPr>
       </a:pPr>
-      <a:endParaRPr lang="en-US"/>
+      <a:endParaRPr lang="ja-JP"/>
     </a:p>
   </c:txPr>
   <c:externalData r:id="rId1">
@@ -501,7 +501,7 @@
             <a:lstStyle/>
             <a:p>
               <a:pPr>
-                <a:defRPr sz="2300">
+                <a:defRPr sz="2300" lang="ja-JP">
                   <a:latin typeface="游ゴシック"/>
                 </a:defRPr>
               </a:pPr>
@@ -543,7 +543,7 @@
           <a:lstStyle/>
           <a:p>
             <a:pPr>
-              <a:defRPr sz="2400"/>
+              <a:defRPr sz="2400" lang="ja-JP"/>
             </a:pPr>
           </a:p>
         </c:txPr>
@@ -584,7 +584,7 @@
           <a:lstStyle/>
           <a:p>
             <a:pPr>
-              <a:defRPr sz="2400">
+              <a:defRPr sz="2400" lang="ja-JP">
                 <a:solidFill>
                   <a:srgbClr val="595959"/>
                 </a:solidFill>
@@ -605,7 +605,7 @@
         <a:lstStyle/>
         <a:p>
           <a:pPr>
-            <a:defRPr sz="2400">
+            <a:defRPr sz="2400" lang="ja-JP">
               <a:latin typeface="游ゴシック"/>
             </a:defRPr>
           </a:pPr>
@@ -619,12 +619,12 @@
     <a:lstStyle/>
     <a:p>
       <a:pPr>
-        <a:defRPr sz="2400">
+        <a:defRPr sz="2400" lang="ja-JP">
           <a:latin typeface="游ゴシック"/>
           <a:ea typeface="游ゴシック"/>
         </a:defRPr>
       </a:pPr>
-      <a:endParaRPr lang="en-US"/>
+      <a:endParaRPr lang="ja-JP"/>
     </a:p>
   </c:txPr>
   <c:externalData r:id="rId1">
@@ -945,7 +945,7 @@
           <a:lstStyle/>
           <a:p>
             <a:pPr>
-              <a:defRPr sz="2000"/>
+              <a:defRPr sz="2000" lang="ja-JP"/>
             </a:pPr>
           </a:p>
         </c:txPr>
@@ -980,7 +980,7 @@
               <a:lstStyle/>
               <a:p>
                 <a:r>
-                  <a:rPr sz="2000"/>
+                  <a:rPr sz="2000" lang="ja-JP"/>
                   <a:t>第16層の比（%）</a:t>
                 </a:r>
               </a:p>
@@ -1002,7 +1002,7 @@
           <a:lstStyle/>
           <a:p>
             <a:pPr>
-              <a:defRPr sz="2000">
+              <a:defRPr sz="2000" lang="ja-JP">
                 <a:solidFill>
                   <a:srgbClr val="595959"/>
                 </a:solidFill>
@@ -1023,7 +1023,7 @@
         <a:lstStyle/>
         <a:p>
           <a:pPr>
-            <a:defRPr sz="2000">
+            <a:defRPr sz="2000" lang="ja-JP">
               <a:latin typeface="游ゴシック"/>
             </a:defRPr>
           </a:pPr>
@@ -1037,12 +1037,12 @@
     <a:lstStyle/>
     <a:p>
       <a:pPr>
-        <a:defRPr sz="2000">
+        <a:defRPr sz="2000" lang="ja-JP">
           <a:latin typeface="游ゴシック"/>
           <a:ea typeface="游ゴシック"/>
         </a:defRPr>
       </a:pPr>
-      <a:endParaRPr lang="en-US"/>
+      <a:endParaRPr lang="ja-JP"/>
     </a:p>
   </c:txPr>
   <c:externalData r:id="rId1">
@@ -1089,10 +1089,10 @@
           <a:lstStyle/>
           <a:p>
             <a:r>
-              <a:rPr lang="en-US" smtClean="0"/>
+              <a:rPr lang="ja-JP" smtClean="0"/>
               <a:t>Click to edit Master title style</a:t>
             </a:r>
-            <a:endParaRPr lang="en-US"/>
+            <a:endParaRPr lang="ja-JP"/>
           </a:p>
         </p:txBody>
       </p:sp>
@@ -1117,7 +1117,7 @@
           <a:lstStyle>
             <a:lvl1pPr marL="0" indent="0" algn="ctr">
               <a:buNone/>
-              <a:defRPr>
+              <a:defRPr lang="ja-JP">
                 <a:solidFill>
                   <a:schemeClr val="tx1">
                     <a:tint val="75000"/>
@@ -1127,7 +1127,7 @@
             </a:lvl1pPr>
             <a:lvl2pPr marL="457200" indent="0" algn="ctr">
               <a:buNone/>
-              <a:defRPr>
+              <a:defRPr lang="ja-JP">
                 <a:solidFill>
                   <a:schemeClr val="tx1">
                     <a:tint val="75000"/>
@@ -1137,7 +1137,7 @@
             </a:lvl2pPr>
             <a:lvl3pPr marL="914400" indent="0" algn="ctr">
               <a:buNone/>
-              <a:defRPr>
+              <a:defRPr lang="ja-JP">
                 <a:solidFill>
                   <a:schemeClr val="tx1">
                     <a:tint val="75000"/>
@@ -1147,7 +1147,7 @@
             </a:lvl3pPr>
             <a:lvl4pPr marL="1371600" indent="0" algn="ctr">
               <a:buNone/>
-              <a:defRPr>
+              <a:defRPr lang="ja-JP">
                 <a:solidFill>
                   <a:schemeClr val="tx1">
                     <a:tint val="75000"/>
@@ -1157,7 +1157,7 @@
             </a:lvl4pPr>
             <a:lvl5pPr marL="1828800" indent="0" algn="ctr">
               <a:buNone/>
-              <a:defRPr>
+              <a:defRPr lang="ja-JP">
                 <a:solidFill>
                   <a:schemeClr val="tx1">
                     <a:tint val="75000"/>
@@ -1167,7 +1167,7 @@
             </a:lvl5pPr>
             <a:lvl6pPr marL="2286000" indent="0" algn="ctr">
               <a:buNone/>
-              <a:defRPr>
+              <a:defRPr lang="ja-JP">
                 <a:solidFill>
                   <a:schemeClr val="tx1">
                     <a:tint val="75000"/>
@@ -1177,7 +1177,7 @@
             </a:lvl6pPr>
             <a:lvl7pPr marL="2743200" indent="0" algn="ctr">
               <a:buNone/>
-              <a:defRPr>
+              <a:defRPr lang="ja-JP">
                 <a:solidFill>
                   <a:schemeClr val="tx1">
                     <a:tint val="75000"/>
@@ -1187,7 +1187,7 @@
             </a:lvl7pPr>
             <a:lvl8pPr marL="3200400" indent="0" algn="ctr">
               <a:buNone/>
-              <a:defRPr>
+              <a:defRPr lang="ja-JP">
                 <a:solidFill>
                   <a:schemeClr val="tx1">
                     <a:tint val="75000"/>
@@ -1197,7 +1197,7 @@
             </a:lvl8pPr>
             <a:lvl9pPr marL="3657600" indent="0" algn="ctr">
               <a:buNone/>
-              <a:defRPr>
+              <a:defRPr lang="ja-JP">
                 <a:solidFill>
                   <a:schemeClr val="tx1">
                     <a:tint val="75000"/>
@@ -1208,10 +1208,10 @@
           </a:lstStyle>
           <a:p>
             <a:r>
-              <a:rPr lang="en-US" smtClean="0"/>
+              <a:rPr lang="ja-JP" smtClean="0"/>
               <a:t>Click to edit Master subtitle style</a:t>
             </a:r>
-            <a:endParaRPr lang="en-US"/>
+            <a:endParaRPr lang="ja-JP"/>
           </a:p>
         </p:txBody>
       </p:sp>
@@ -1231,10 +1231,10 @@
           <a:lstStyle/>
           <a:p>
             <a:fld id="{5BCAD085-E8A6-8845-BD4E-CB4CCA059FC4}" type="datetimeFigureOut">
-              <a:rPr lang="en-US" smtClean="0"/>
+              <a:rPr lang="ja-JP" smtClean="0"/>
               <a:t>1/27/13</a:t>
             </a:fld>
-            <a:endParaRPr lang="en-US"/>
+            <a:endParaRPr lang="ja-JP"/>
           </a:p>
         </p:txBody>
       </p:sp>
@@ -1253,7 +1253,7 @@
           <a:bodyPr/>
           <a:lstStyle/>
           <a:p>
-            <a:endParaRPr lang="en-US"/>
+            <a:endParaRPr lang="ja-JP"/>
           </a:p>
         </p:txBody>
       </p:sp>
@@ -1273,10 +1273,10 @@
           <a:lstStyle/>
           <a:p>
             <a:fld id="{C1FF6DA9-008F-8B48-92A6-B652298478BF}" type="slidenum">
-              <a:rPr lang="en-US" smtClean="0"/>
+              <a:rPr lang="ja-JP" smtClean="0"/>
               <a:t>‹#›</a:t>
             </a:fld>
-            <a:endParaRPr lang="en-US"/>
+            <a:endParaRPr lang="ja-JP"/>
           </a:p>
         </p:txBody>
       </p:sp>
@@ -1326,10 +1326,10 @@
           <a:lstStyle/>
           <a:p>
             <a:r>
-              <a:rPr lang="en-US" smtClean="0"/>
+              <a:rPr lang="ja-JP" smtClean="0"/>
               <a:t>Click to edit Master title style</a:t>
             </a:r>
-            <a:endParaRPr lang="en-US"/>
+            <a:endParaRPr lang="ja-JP"/>
           </a:p>
         </p:txBody>
       </p:sp>
@@ -1350,38 +1350,38 @@
           <a:p>
             <a:pPr lvl="0"/>
             <a:r>
-              <a:rPr lang="en-US" smtClean="0"/>
+              <a:rPr lang="ja-JP" smtClean="0"/>
               <a:t>Click to edit Master text styles</a:t>
             </a:r>
           </a:p>
           <a:p>
             <a:pPr lvl="1"/>
             <a:r>
-              <a:rPr lang="en-US" smtClean="0"/>
+              <a:rPr lang="ja-JP" smtClean="0"/>
               <a:t>Second level</a:t>
             </a:r>
           </a:p>
           <a:p>
             <a:pPr lvl="2"/>
             <a:r>
-              <a:rPr lang="en-US" smtClean="0"/>
+              <a:rPr lang="ja-JP" smtClean="0"/>
               <a:t>Third level</a:t>
             </a:r>
           </a:p>
           <a:p>
             <a:pPr lvl="3"/>
             <a:r>
-              <a:rPr lang="en-US" smtClean="0"/>
+              <a:rPr lang="ja-JP" smtClean="0"/>
               <a:t>Fourth level</a:t>
             </a:r>
           </a:p>
           <a:p>
             <a:pPr lvl="4"/>
             <a:r>
-              <a:rPr lang="en-US" smtClean="0"/>
+              <a:rPr lang="ja-JP" smtClean="0"/>
               <a:t>Fifth level</a:t>
             </a:r>
-            <a:endParaRPr lang="en-US"/>
+            <a:endParaRPr lang="ja-JP"/>
           </a:p>
         </p:txBody>
       </p:sp>
@@ -1401,10 +1401,10 @@
           <a:lstStyle/>
           <a:p>
             <a:fld id="{5BCAD085-E8A6-8845-BD4E-CB4CCA059FC4}" type="datetimeFigureOut">
-              <a:rPr lang="en-US" smtClean="0"/>
+              <a:rPr lang="ja-JP" smtClean="0"/>
               <a:t>1/27/13</a:t>
             </a:fld>
-            <a:endParaRPr lang="en-US"/>
+            <a:endParaRPr lang="ja-JP"/>
           </a:p>
         </p:txBody>
       </p:sp>
@@ -1423,7 +1423,7 @@
           <a:bodyPr/>
           <a:lstStyle/>
           <a:p>
-            <a:endParaRPr lang="en-US"/>
+            <a:endParaRPr lang="ja-JP"/>
           </a:p>
         </p:txBody>
       </p:sp>
@@ -1443,10 +1443,10 @@
           <a:lstStyle/>
           <a:p>
             <a:fld id="{C1FF6DA9-008F-8B48-92A6-B652298478BF}" type="slidenum">
-              <a:rPr lang="en-US" smtClean="0"/>
+              <a:rPr lang="ja-JP" smtClean="0"/>
               <a:t>‹#›</a:t>
             </a:fld>
-            <a:endParaRPr lang="en-US"/>
+            <a:endParaRPr lang="ja-JP"/>
           </a:p>
         </p:txBody>
       </p:sp>
@@ -1501,10 +1501,10 @@
           <a:lstStyle/>
           <a:p>
             <a:r>
-              <a:rPr lang="en-US" smtClean="0"/>
+              <a:rPr lang="ja-JP" smtClean="0"/>
               <a:t>Click to edit Master title style</a:t>
             </a:r>
-            <a:endParaRPr lang="en-US"/>
+            <a:endParaRPr lang="ja-JP"/>
           </a:p>
         </p:txBody>
       </p:sp>
@@ -1530,38 +1530,38 @@
           <a:p>
             <a:pPr lvl="0"/>
             <a:r>
-              <a:rPr lang="en-US" smtClean="0"/>
+              <a:rPr lang="ja-JP" smtClean="0"/>
               <a:t>Click to edit Master text styles</a:t>
             </a:r>
           </a:p>
           <a:p>
             <a:pPr lvl="1"/>
             <a:r>
-              <a:rPr lang="en-US" smtClean="0"/>
+              <a:rPr lang="ja-JP" smtClean="0"/>
               <a:t>Second level</a:t>
             </a:r>
           </a:p>
           <a:p>
             <a:pPr lvl="2"/>
             <a:r>
-              <a:rPr lang="en-US" smtClean="0"/>
+              <a:rPr lang="ja-JP" smtClean="0"/>
               <a:t>Third level</a:t>
             </a:r>
           </a:p>
           <a:p>
             <a:pPr lvl="3"/>
             <a:r>
-              <a:rPr lang="en-US" smtClean="0"/>
+              <a:rPr lang="ja-JP" smtClean="0"/>
               <a:t>Fourth level</a:t>
             </a:r>
           </a:p>
           <a:p>
             <a:pPr lvl="4"/>
             <a:r>
-              <a:rPr lang="en-US" smtClean="0"/>
+              <a:rPr lang="ja-JP" smtClean="0"/>
               <a:t>Fifth level</a:t>
             </a:r>
-            <a:endParaRPr lang="en-US"/>
+            <a:endParaRPr lang="ja-JP"/>
           </a:p>
         </p:txBody>
       </p:sp>
@@ -1581,10 +1581,10 @@
           <a:lstStyle/>
           <a:p>
             <a:fld id="{5BCAD085-E8A6-8845-BD4E-CB4CCA059FC4}" type="datetimeFigureOut">
-              <a:rPr lang="en-US" smtClean="0"/>
+              <a:rPr lang="ja-JP" smtClean="0"/>
               <a:t>1/27/13</a:t>
             </a:fld>
-            <a:endParaRPr lang="en-US"/>
+            <a:endParaRPr lang="ja-JP"/>
           </a:p>
         </p:txBody>
       </p:sp>
@@ -1603,7 +1603,7 @@
           <a:bodyPr/>
           <a:lstStyle/>
           <a:p>
-            <a:endParaRPr lang="en-US"/>
+            <a:endParaRPr lang="ja-JP"/>
           </a:p>
         </p:txBody>
       </p:sp>
@@ -1623,10 +1623,10 @@
           <a:lstStyle/>
           <a:p>
             <a:fld id="{C1FF6DA9-008F-8B48-92A6-B652298478BF}" type="slidenum">
-              <a:rPr lang="en-US" smtClean="0"/>
+              <a:rPr lang="ja-JP" smtClean="0"/>
               <a:t>‹#›</a:t>
             </a:fld>
-            <a:endParaRPr lang="en-US"/>
+            <a:endParaRPr lang="ja-JP"/>
           </a:p>
         </p:txBody>
       </p:sp>
@@ -1676,10 +1676,10 @@
           <a:lstStyle/>
           <a:p>
             <a:r>
-              <a:rPr lang="en-US" smtClean="0"/>
+              <a:rPr lang="ja-JP" smtClean="0"/>
               <a:t>Click to edit Master title style</a:t>
             </a:r>
-            <a:endParaRPr lang="en-US"/>
+            <a:endParaRPr lang="ja-JP"/>
           </a:p>
         </p:txBody>
       </p:sp>
@@ -1700,38 +1700,38 @@
           <a:p>
             <a:pPr lvl="0"/>
             <a:r>
-              <a:rPr lang="en-US" smtClean="0"/>
+              <a:rPr lang="ja-JP" smtClean="0"/>
               <a:t>Click to edit Master text styles</a:t>
             </a:r>
           </a:p>
           <a:p>
             <a:pPr lvl="1"/>
             <a:r>
-              <a:rPr lang="en-US" smtClean="0"/>
+              <a:rPr lang="ja-JP" smtClean="0"/>
               <a:t>Second level</a:t>
             </a:r>
           </a:p>
           <a:p>
             <a:pPr lvl="2"/>
             <a:r>
-              <a:rPr lang="en-US" smtClean="0"/>
+              <a:rPr lang="ja-JP" smtClean="0"/>
               <a:t>Third level</a:t>
             </a:r>
           </a:p>
           <a:p>
             <a:pPr lvl="3"/>
             <a:r>
-              <a:rPr lang="en-US" smtClean="0"/>
+              <a:rPr lang="ja-JP" smtClean="0"/>
               <a:t>Fourth level</a:t>
             </a:r>
           </a:p>
           <a:p>
             <a:pPr lvl="4"/>
             <a:r>
-              <a:rPr lang="en-US" smtClean="0"/>
+              <a:rPr lang="ja-JP" smtClean="0"/>
               <a:t>Fifth level</a:t>
             </a:r>
-            <a:endParaRPr lang="en-US"/>
+            <a:endParaRPr lang="ja-JP"/>
           </a:p>
         </p:txBody>
       </p:sp>
@@ -1751,10 +1751,10 @@
           <a:lstStyle/>
           <a:p>
             <a:fld id="{5BCAD085-E8A6-8845-BD4E-CB4CCA059FC4}" type="datetimeFigureOut">
-              <a:rPr lang="en-US" smtClean="0"/>
+              <a:rPr lang="ja-JP" smtClean="0"/>
               <a:t>1/27/13</a:t>
             </a:fld>
-            <a:endParaRPr lang="en-US"/>
+            <a:endParaRPr lang="ja-JP"/>
           </a:p>
         </p:txBody>
       </p:sp>
@@ -1773,7 +1773,7 @@
           <a:bodyPr/>
           <a:lstStyle/>
           <a:p>
-            <a:endParaRPr lang="en-US"/>
+            <a:endParaRPr lang="ja-JP"/>
           </a:p>
         </p:txBody>
       </p:sp>
@@ -1793,10 +1793,10 @@
           <a:lstStyle/>
           <a:p>
             <a:fld id="{C1FF6DA9-008F-8B48-92A6-B652298478BF}" type="slidenum">
-              <a:rPr lang="en-US" smtClean="0"/>
+              <a:rPr lang="ja-JP" smtClean="0"/>
               <a:t>‹#›</a:t>
             </a:fld>
-            <a:endParaRPr lang="en-US"/>
+            <a:endParaRPr lang="ja-JP"/>
           </a:p>
         </p:txBody>
       </p:sp>
@@ -1850,15 +1850,15 @@
           <a:bodyPr anchor="t"/>
           <a:lstStyle>
             <a:lvl1pPr algn="l">
-              <a:defRPr sz="4000" b="1" cap="all"/>
+              <a:defRPr sz="4000" b="1" cap="all" lang="ja-JP"/>
             </a:lvl1pPr>
           </a:lstStyle>
           <a:p>
             <a:r>
-              <a:rPr lang="en-US" smtClean="0"/>
+              <a:rPr lang="ja-JP" smtClean="0"/>
               <a:t>Click to edit Master title style</a:t>
             </a:r>
-            <a:endParaRPr lang="en-US"/>
+            <a:endParaRPr lang="ja-JP"/>
           </a:p>
         </p:txBody>
       </p:sp>
@@ -1883,7 +1883,7 @@
           <a:lstStyle>
             <a:lvl1pPr marL="0" indent="0">
               <a:buNone/>
-              <a:defRPr sz="2000">
+              <a:defRPr sz="2000" lang="ja-JP">
                 <a:solidFill>
                   <a:schemeClr val="tx1">
                     <a:tint val="75000"/>
@@ -1893,7 +1893,7 @@
             </a:lvl1pPr>
             <a:lvl2pPr marL="457200" indent="0">
               <a:buNone/>
-              <a:defRPr sz="1800">
+              <a:defRPr sz="1800" lang="ja-JP">
                 <a:solidFill>
                   <a:schemeClr val="tx1">
                     <a:tint val="75000"/>
@@ -1903,7 +1903,7 @@
             </a:lvl2pPr>
             <a:lvl3pPr marL="914400" indent="0">
               <a:buNone/>
-              <a:defRPr sz="1600">
+              <a:defRPr sz="1600" lang="ja-JP">
                 <a:solidFill>
                   <a:schemeClr val="tx1">
                     <a:tint val="75000"/>
@@ -1913,7 +1913,7 @@
             </a:lvl3pPr>
             <a:lvl4pPr marL="1371600" indent="0">
               <a:buNone/>
-              <a:defRPr sz="1400">
+              <a:defRPr sz="1400" lang="ja-JP">
                 <a:solidFill>
                   <a:schemeClr val="tx1">
                     <a:tint val="75000"/>
@@ -1923,7 +1923,7 @@
             </a:lvl4pPr>
             <a:lvl5pPr marL="1828800" indent="0">
               <a:buNone/>
-              <a:defRPr sz="1400">
+              <a:defRPr sz="1400" lang="ja-JP">
                 <a:solidFill>
                   <a:schemeClr val="tx1">
                     <a:tint val="75000"/>
@@ -1933,7 +1933,7 @@
             </a:lvl5pPr>
             <a:lvl6pPr marL="2286000" indent="0">
               <a:buNone/>
-              <a:defRPr sz="1400">
+              <a:defRPr sz="1400" lang="ja-JP">
                 <a:solidFill>
                   <a:schemeClr val="tx1">
                     <a:tint val="75000"/>
@@ -1943,7 +1943,7 @@
             </a:lvl6pPr>
             <a:lvl7pPr marL="2743200" indent="0">
               <a:buNone/>
-              <a:defRPr sz="1400">
+              <a:defRPr sz="1400" lang="ja-JP">
                 <a:solidFill>
                   <a:schemeClr val="tx1">
                     <a:tint val="75000"/>
@@ -1953,7 +1953,7 @@
             </a:lvl7pPr>
             <a:lvl8pPr marL="3200400" indent="0">
               <a:buNone/>
-              <a:defRPr sz="1400">
+              <a:defRPr sz="1400" lang="ja-JP">
                 <a:solidFill>
                   <a:schemeClr val="tx1">
                     <a:tint val="75000"/>
@@ -1963,7 +1963,7 @@
             </a:lvl8pPr>
             <a:lvl9pPr marL="3657600" indent="0">
               <a:buNone/>
-              <a:defRPr sz="1400">
+              <a:defRPr sz="1400" lang="ja-JP">
                 <a:solidFill>
                   <a:schemeClr val="tx1">
                     <a:tint val="75000"/>
@@ -1975,7 +1975,7 @@
           <a:p>
             <a:pPr lvl="0"/>
             <a:r>
-              <a:rPr lang="en-US" smtClean="0"/>
+              <a:rPr lang="ja-JP" smtClean="0"/>
               <a:t>Click to edit Master text styles</a:t>
             </a:r>
           </a:p>
@@ -1997,10 +1997,10 @@
           <a:lstStyle/>
           <a:p>
             <a:fld id="{5BCAD085-E8A6-8845-BD4E-CB4CCA059FC4}" type="datetimeFigureOut">
-              <a:rPr lang="en-US" smtClean="0"/>
+              <a:rPr lang="ja-JP" smtClean="0"/>
               <a:t>1/27/13</a:t>
             </a:fld>
-            <a:endParaRPr lang="en-US"/>
+            <a:endParaRPr lang="ja-JP"/>
           </a:p>
         </p:txBody>
       </p:sp>
@@ -2019,7 +2019,7 @@
           <a:bodyPr/>
           <a:lstStyle/>
           <a:p>
-            <a:endParaRPr lang="en-US"/>
+            <a:endParaRPr lang="ja-JP"/>
           </a:p>
         </p:txBody>
       </p:sp>
@@ -2039,10 +2039,10 @@
           <a:lstStyle/>
           <a:p>
             <a:fld id="{C1FF6DA9-008F-8B48-92A6-B652298478BF}" type="slidenum">
-              <a:rPr lang="en-US" smtClean="0"/>
+              <a:rPr lang="ja-JP" smtClean="0"/>
               <a:t>‹#›</a:t>
             </a:fld>
-            <a:endParaRPr lang="en-US"/>
+            <a:endParaRPr lang="ja-JP"/>
           </a:p>
         </p:txBody>
       </p:sp>
@@ -2092,10 +2092,10 @@
           <a:lstStyle/>
           <a:p>
             <a:r>
-              <a:rPr lang="en-US" smtClean="0"/>
+              <a:rPr lang="ja-JP" smtClean="0"/>
               <a:t>Click to edit Master title style</a:t>
             </a:r>
-            <a:endParaRPr lang="en-US"/>
+            <a:endParaRPr lang="ja-JP"/>
           </a:p>
         </p:txBody>
       </p:sp>
@@ -2119,68 +2119,68 @@
           <a:bodyPr/>
           <a:lstStyle>
             <a:lvl1pPr>
-              <a:defRPr sz="2800"/>
+              <a:defRPr sz="2800" lang="ja-JP"/>
             </a:lvl1pPr>
             <a:lvl2pPr>
-              <a:defRPr sz="2400"/>
+              <a:defRPr sz="2400" lang="ja-JP"/>
             </a:lvl2pPr>
             <a:lvl3pPr>
-              <a:defRPr sz="2000"/>
+              <a:defRPr sz="2000" lang="ja-JP"/>
             </a:lvl3pPr>
             <a:lvl4pPr>
-              <a:defRPr sz="1800"/>
+              <a:defRPr sz="1800" lang="ja-JP"/>
             </a:lvl4pPr>
             <a:lvl5pPr>
-              <a:defRPr sz="1800"/>
+              <a:defRPr sz="1800" lang="ja-JP"/>
             </a:lvl5pPr>
             <a:lvl6pPr>
-              <a:defRPr sz="1800"/>
+              <a:defRPr sz="1800" lang="ja-JP"/>
             </a:lvl6pPr>
             <a:lvl7pPr>
-              <a:defRPr sz="1800"/>
+              <a:defRPr sz="1800" lang="ja-JP"/>
             </a:lvl7pPr>
             <a:lvl8pPr>
-              <a:defRPr sz="1800"/>
+              <a:defRPr sz="1800" lang="ja-JP"/>
             </a:lvl8pPr>
             <a:lvl9pPr>
-              <a:defRPr sz="1800"/>
+              <a:defRPr sz="1800" lang="ja-JP"/>
             </a:lvl9pPr>
           </a:lstStyle>
           <a:p>
             <a:pPr lvl="0"/>
             <a:r>
-              <a:rPr lang="en-US" smtClean="0"/>
+              <a:rPr lang="ja-JP" smtClean="0"/>
               <a:t>Click to edit Master text styles</a:t>
             </a:r>
           </a:p>
           <a:p>
             <a:pPr lvl="1"/>
             <a:r>
-              <a:rPr lang="en-US" smtClean="0"/>
+              <a:rPr lang="ja-JP" smtClean="0"/>
               <a:t>Second level</a:t>
             </a:r>
           </a:p>
           <a:p>
             <a:pPr lvl="2"/>
             <a:r>
-              <a:rPr lang="en-US" smtClean="0"/>
+              <a:rPr lang="ja-JP" smtClean="0"/>
               <a:t>Third level</a:t>
             </a:r>
           </a:p>
           <a:p>
             <a:pPr lvl="3"/>
             <a:r>
-              <a:rPr lang="en-US" smtClean="0"/>
+              <a:rPr lang="ja-JP" smtClean="0"/>
               <a:t>Fourth level</a:t>
             </a:r>
           </a:p>
           <a:p>
             <a:pPr lvl="4"/>
             <a:r>
-              <a:rPr lang="en-US" smtClean="0"/>
+              <a:rPr lang="ja-JP" smtClean="0"/>
               <a:t>Fifth level</a:t>
             </a:r>
-            <a:endParaRPr lang="en-US"/>
+            <a:endParaRPr lang="ja-JP"/>
           </a:p>
         </p:txBody>
       </p:sp>
@@ -2204,68 +2204,68 @@
           <a:bodyPr/>
           <a:lstStyle>
             <a:lvl1pPr>
-              <a:defRPr sz="2800"/>
+              <a:defRPr sz="2800" lang="ja-JP"/>
             </a:lvl1pPr>
             <a:lvl2pPr>
-              <a:defRPr sz="2400"/>
+              <a:defRPr sz="2400" lang="ja-JP"/>
             </a:lvl2pPr>
             <a:lvl3pPr>
-              <a:defRPr sz="2000"/>
+              <a:defRPr sz="2000" lang="ja-JP"/>
             </a:lvl3pPr>
             <a:lvl4pPr>
-              <a:defRPr sz="1800"/>
+              <a:defRPr sz="1800" lang="ja-JP"/>
             </a:lvl4pPr>
             <a:lvl5pPr>
-              <a:defRPr sz="1800"/>
+              <a:defRPr sz="1800" lang="ja-JP"/>
             </a:lvl5pPr>
             <a:lvl6pPr>
-              <a:defRPr sz="1800"/>
+              <a:defRPr sz="1800" lang="ja-JP"/>
             </a:lvl6pPr>
             <a:lvl7pPr>
-              <a:defRPr sz="1800"/>
+              <a:defRPr sz="1800" lang="ja-JP"/>
             </a:lvl7pPr>
             <a:lvl8pPr>
-              <a:defRPr sz="1800"/>
+              <a:defRPr sz="1800" lang="ja-JP"/>
             </a:lvl8pPr>
             <a:lvl9pPr>
-              <a:defRPr sz="1800"/>
+              <a:defRPr sz="1800" lang="ja-JP"/>
             </a:lvl9pPr>
           </a:lstStyle>
           <a:p>
             <a:pPr lvl="0"/>
             <a:r>
-              <a:rPr lang="en-US" smtClean="0"/>
+              <a:rPr lang="ja-JP" smtClean="0"/>
               <a:t>Click to edit Master text styles</a:t>
             </a:r>
           </a:p>
           <a:p>
             <a:pPr lvl="1"/>
             <a:r>
-              <a:rPr lang="en-US" smtClean="0"/>
+              <a:rPr lang="ja-JP" smtClean="0"/>
               <a:t>Second level</a:t>
             </a:r>
           </a:p>
           <a:p>
             <a:pPr lvl="2"/>
             <a:r>
-              <a:rPr lang="en-US" smtClean="0"/>
+              <a:rPr lang="ja-JP" smtClean="0"/>
               <a:t>Third level</a:t>
             </a:r>
           </a:p>
           <a:p>
             <a:pPr lvl="3"/>
             <a:r>
-              <a:rPr lang="en-US" smtClean="0"/>
+              <a:rPr lang="ja-JP" smtClean="0"/>
               <a:t>Fourth level</a:t>
             </a:r>
           </a:p>
           <a:p>
             <a:pPr lvl="4"/>
             <a:r>
-              <a:rPr lang="en-US" smtClean="0"/>
+              <a:rPr lang="ja-JP" smtClean="0"/>
               <a:t>Fifth level</a:t>
             </a:r>
-            <a:endParaRPr lang="en-US"/>
+            <a:endParaRPr lang="ja-JP"/>
           </a:p>
         </p:txBody>
       </p:sp>
@@ -2285,10 +2285,10 @@
           <a:lstStyle/>
           <a:p>
             <a:fld id="{5BCAD085-E8A6-8845-BD4E-CB4CCA059FC4}" type="datetimeFigureOut">
-              <a:rPr lang="en-US" smtClean="0"/>
+              <a:rPr lang="ja-JP" smtClean="0"/>
               <a:t>1/27/13</a:t>
             </a:fld>
-            <a:endParaRPr lang="en-US"/>
+            <a:endParaRPr lang="ja-JP"/>
           </a:p>
         </p:txBody>
       </p:sp>
@@ -2307,7 +2307,7 @@
           <a:bodyPr/>
           <a:lstStyle/>
           <a:p>
-            <a:endParaRPr lang="en-US"/>
+            <a:endParaRPr lang="ja-JP"/>
           </a:p>
         </p:txBody>
       </p:sp>
@@ -2327,10 +2327,10 @@
           <a:lstStyle/>
           <a:p>
             <a:fld id="{C1FF6DA9-008F-8B48-92A6-B652298478BF}" type="slidenum">
-              <a:rPr lang="en-US" smtClean="0"/>
+              <a:rPr lang="ja-JP" smtClean="0"/>
               <a:t>‹#›</a:t>
             </a:fld>
-            <a:endParaRPr lang="en-US"/>
+            <a:endParaRPr lang="ja-JP"/>
           </a:p>
         </p:txBody>
       </p:sp>
@@ -2379,15 +2379,15 @@
           <a:bodyPr/>
           <a:lstStyle>
             <a:lvl1pPr>
-              <a:defRPr/>
+              <a:defRPr lang="ja-JP"/>
             </a:lvl1pPr>
           </a:lstStyle>
           <a:p>
             <a:r>
-              <a:rPr lang="en-US" smtClean="0"/>
+              <a:rPr lang="ja-JP" smtClean="0"/>
               <a:t>Click to edit Master title style</a:t>
             </a:r>
-            <a:endParaRPr lang="en-US"/>
+            <a:endParaRPr lang="ja-JP"/>
           </a:p>
         </p:txBody>
       </p:sp>
@@ -2412,45 +2412,45 @@
           <a:lstStyle>
             <a:lvl1pPr marL="0" indent="0">
               <a:buNone/>
-              <a:defRPr sz="2400" b="1"/>
+              <a:defRPr sz="2400" b="1" lang="ja-JP"/>
             </a:lvl1pPr>
             <a:lvl2pPr marL="457200" indent="0">
               <a:buNone/>
-              <a:defRPr sz="2000" b="1"/>
+              <a:defRPr sz="2000" b="1" lang="ja-JP"/>
             </a:lvl2pPr>
             <a:lvl3pPr marL="914400" indent="0">
               <a:buNone/>
-              <a:defRPr sz="1800" b="1"/>
+              <a:defRPr sz="1800" b="1" lang="ja-JP"/>
             </a:lvl3pPr>
             <a:lvl4pPr marL="1371600" indent="0">
               <a:buNone/>
-              <a:defRPr sz="1600" b="1"/>
+              <a:defRPr sz="1600" b="1" lang="ja-JP"/>
             </a:lvl4pPr>
             <a:lvl5pPr marL="1828800" indent="0">
               <a:buNone/>
-              <a:defRPr sz="1600" b="1"/>
+              <a:defRPr sz="1600" b="1" lang="ja-JP"/>
             </a:lvl5pPr>
             <a:lvl6pPr marL="2286000" indent="0">
               <a:buNone/>
-              <a:defRPr sz="1600" b="1"/>
+              <a:defRPr sz="1600" b="1" lang="ja-JP"/>
             </a:lvl6pPr>
             <a:lvl7pPr marL="2743200" indent="0">
               <a:buNone/>
-              <a:defRPr sz="1600" b="1"/>
+              <a:defRPr sz="1600" b="1" lang="ja-JP"/>
             </a:lvl7pPr>
             <a:lvl8pPr marL="3200400" indent="0">
               <a:buNone/>
-              <a:defRPr sz="1600" b="1"/>
+              <a:defRPr sz="1600" b="1" lang="ja-JP"/>
             </a:lvl8pPr>
             <a:lvl9pPr marL="3657600" indent="0">
               <a:buNone/>
-              <a:defRPr sz="1600" b="1"/>
+              <a:defRPr sz="1600" b="1" lang="ja-JP"/>
             </a:lvl9pPr>
           </a:lstStyle>
           <a:p>
             <a:pPr lvl="0"/>
             <a:r>
-              <a:rPr lang="en-US" smtClean="0"/>
+              <a:rPr lang="ja-JP" smtClean="0"/>
               <a:t>Click to edit Master text styles</a:t>
             </a:r>
           </a:p>
@@ -2476,68 +2476,68 @@
           <a:bodyPr/>
           <a:lstStyle>
             <a:lvl1pPr>
-              <a:defRPr sz="2400"/>
+              <a:defRPr sz="2400" lang="ja-JP"/>
             </a:lvl1pPr>
             <a:lvl2pPr>
-              <a:defRPr sz="2000"/>
+              <a:defRPr sz="2000" lang="ja-JP"/>
             </a:lvl2pPr>
             <a:lvl3pPr>
-              <a:defRPr sz="1800"/>
+              <a:defRPr sz="1800" lang="ja-JP"/>
             </a:lvl3pPr>
             <a:lvl4pPr>
-              <a:defRPr sz="1600"/>
+              <a:defRPr sz="1600" lang="ja-JP"/>
             </a:lvl4pPr>
             <a:lvl5pPr>
-              <a:defRPr sz="1600"/>
+              <a:defRPr sz="1600" lang="ja-JP"/>
             </a:lvl5pPr>
             <a:lvl6pPr>
-              <a:defRPr sz="1600"/>
+              <a:defRPr sz="1600" lang="ja-JP"/>
             </a:lvl6pPr>
             <a:lvl7pPr>
-              <a:defRPr sz="1600"/>
+              <a:defRPr sz="1600" lang="ja-JP"/>
             </a:lvl7pPr>
             <a:lvl8pPr>
-              <a:defRPr sz="1600"/>
+              <a:defRPr sz="1600" lang="ja-JP"/>
             </a:lvl8pPr>
             <a:lvl9pPr>
-              <a:defRPr sz="1600"/>
+              <a:defRPr sz="1600" lang="ja-JP"/>
             </a:lvl9pPr>
           </a:lstStyle>
           <a:p>
             <a:pPr lvl="0"/>
             <a:r>
-              <a:rPr lang="en-US" smtClean="0"/>
+              <a:rPr lang="ja-JP" smtClean="0"/>
               <a:t>Click to edit Master text styles</a:t>
             </a:r>
           </a:p>
           <a:p>
             <a:pPr lvl="1"/>
             <a:r>
-              <a:rPr lang="en-US" smtClean="0"/>
+              <a:rPr lang="ja-JP" smtClean="0"/>
               <a:t>Second level</a:t>
             </a:r>
           </a:p>
           <a:p>
             <a:pPr lvl="2"/>
             <a:r>
-              <a:rPr lang="en-US" smtClean="0"/>
+              <a:rPr lang="ja-JP" smtClean="0"/>
               <a:t>Third level</a:t>
             </a:r>
           </a:p>
           <a:p>
             <a:pPr lvl="3"/>
             <a:r>
-              <a:rPr lang="en-US" smtClean="0"/>
+              <a:rPr lang="ja-JP" smtClean="0"/>
               <a:t>Fourth level</a:t>
             </a:r>
           </a:p>
           <a:p>
             <a:pPr lvl="4"/>
             <a:r>
-              <a:rPr lang="en-US" smtClean="0"/>
+              <a:rPr lang="ja-JP" smtClean="0"/>
               <a:t>Fifth level</a:t>
             </a:r>
-            <a:endParaRPr lang="en-US"/>
+            <a:endParaRPr lang="ja-JP"/>
           </a:p>
         </p:txBody>
       </p:sp>
@@ -2562,45 +2562,45 @@
           <a:lstStyle>
             <a:lvl1pPr marL="0" indent="0">
               <a:buNone/>
-              <a:defRPr sz="2400" b="1"/>
+              <a:defRPr sz="2400" b="1" lang="ja-JP"/>
             </a:lvl1pPr>
             <a:lvl2pPr marL="457200" indent="0">
               <a:buNone/>
-              <a:defRPr sz="2000" b="1"/>
+              <a:defRPr sz="2000" b="1" lang="ja-JP"/>
             </a:lvl2pPr>
             <a:lvl3pPr marL="914400" indent="0">
               <a:buNone/>
-              <a:defRPr sz="1800" b="1"/>
+              <a:defRPr sz="1800" b="1" lang="ja-JP"/>
             </a:lvl3pPr>
             <a:lvl4pPr marL="1371600" indent="0">
               <a:buNone/>
-              <a:defRPr sz="1600" b="1"/>
+              <a:defRPr sz="1600" b="1" lang="ja-JP"/>
             </a:lvl4pPr>
             <a:lvl5pPr marL="1828800" indent="0">
               <a:buNone/>
-              <a:defRPr sz="1600" b="1"/>
+              <a:defRPr sz="1600" b="1" lang="ja-JP"/>
             </a:lvl5pPr>
             <a:lvl6pPr marL="2286000" indent="0">
               <a:buNone/>
-              <a:defRPr sz="1600" b="1"/>
+              <a:defRPr sz="1600" b="1" lang="ja-JP"/>
             </a:lvl6pPr>
             <a:lvl7pPr marL="2743200" indent="0">
               <a:buNone/>
-              <a:defRPr sz="1600" b="1"/>
+              <a:defRPr sz="1600" b="1" lang="ja-JP"/>
             </a:lvl7pPr>
             <a:lvl8pPr marL="3200400" indent="0">
               <a:buNone/>
-              <a:defRPr sz="1600" b="1"/>
+              <a:defRPr sz="1600" b="1" lang="ja-JP"/>
             </a:lvl8pPr>
             <a:lvl9pPr marL="3657600" indent="0">
               <a:buNone/>
-              <a:defRPr sz="1600" b="1"/>
+              <a:defRPr sz="1600" b="1" lang="ja-JP"/>
             </a:lvl9pPr>
           </a:lstStyle>
           <a:p>
             <a:pPr lvl="0"/>
             <a:r>
-              <a:rPr lang="en-US" smtClean="0"/>
+              <a:rPr lang="ja-JP" smtClean="0"/>
               <a:t>Click to edit Master text styles</a:t>
             </a:r>
           </a:p>
@@ -2626,68 +2626,68 @@
           <a:bodyPr/>
           <a:lstStyle>
             <a:lvl1pPr>
-              <a:defRPr sz="2400"/>
+              <a:defRPr sz="2400" lang="ja-JP"/>
             </a:lvl1pPr>
             <a:lvl2pPr>
-              <a:defRPr sz="2000"/>
+              <a:defRPr sz="2000" lang="ja-JP"/>
             </a:lvl2pPr>
             <a:lvl3pPr>
-              <a:defRPr sz="1800"/>
+              <a:defRPr sz="1800" lang="ja-JP"/>
             </a:lvl3pPr>
             <a:lvl4pPr>
-              <a:defRPr sz="1600"/>
+              <a:defRPr sz="1600" lang="ja-JP"/>
             </a:lvl4pPr>
             <a:lvl5pPr>
-              <a:defRPr sz="1600"/>
+              <a:defRPr sz="1600" lang="ja-JP"/>
             </a:lvl5pPr>
             <a:lvl6pPr>
-              <a:defRPr sz="1600"/>
+              <a:defRPr sz="1600" lang="ja-JP"/>
             </a:lvl6pPr>
             <a:lvl7pPr>
-              <a:defRPr sz="1600"/>
+              <a:defRPr sz="1600" lang="ja-JP"/>
             </a:lvl7pPr>
             <a:lvl8pPr>
-              <a:defRPr sz="1600"/>
+              <a:defRPr sz="1600" lang="ja-JP"/>
             </a:lvl8pPr>
             <a:lvl9pPr>
-              <a:defRPr sz="1600"/>
+              <a:defRPr sz="1600" lang="ja-JP"/>
             </a:lvl9pPr>
           </a:lstStyle>
           <a:p>
             <a:pPr lvl="0"/>
             <a:r>
-              <a:rPr lang="en-US" smtClean="0"/>
+              <a:rPr lang="ja-JP" smtClean="0"/>
               <a:t>Click to edit Master text styles</a:t>
             </a:r>
           </a:p>
           <a:p>
             <a:pPr lvl="1"/>
             <a:r>
-              <a:rPr lang="en-US" smtClean="0"/>
+              <a:rPr lang="ja-JP" smtClean="0"/>
               <a:t>Second level</a:t>
             </a:r>
           </a:p>
           <a:p>
             <a:pPr lvl="2"/>
             <a:r>
-              <a:rPr lang="en-US" smtClean="0"/>
+              <a:rPr lang="ja-JP" smtClean="0"/>
               <a:t>Third level</a:t>
             </a:r>
           </a:p>
           <a:p>
             <a:pPr lvl="3"/>
             <a:r>
-              <a:rPr lang="en-US" smtClean="0"/>
+              <a:rPr lang="ja-JP" smtClean="0"/>
               <a:t>Fourth level</a:t>
             </a:r>
           </a:p>
           <a:p>
             <a:pPr lvl="4"/>
             <a:r>
-              <a:rPr lang="en-US" smtClean="0"/>
+              <a:rPr lang="ja-JP" smtClean="0"/>
               <a:t>Fifth level</a:t>
             </a:r>
-            <a:endParaRPr lang="en-US"/>
+            <a:endParaRPr lang="ja-JP"/>
           </a:p>
         </p:txBody>
       </p:sp>
@@ -2707,10 +2707,10 @@
           <a:lstStyle/>
           <a:p>
             <a:fld id="{5BCAD085-E8A6-8845-BD4E-CB4CCA059FC4}" type="datetimeFigureOut">
-              <a:rPr lang="en-US" smtClean="0"/>
+              <a:rPr lang="ja-JP" smtClean="0"/>
               <a:t>1/27/13</a:t>
             </a:fld>
-            <a:endParaRPr lang="en-US"/>
+            <a:endParaRPr lang="ja-JP"/>
           </a:p>
         </p:txBody>
       </p:sp>
@@ -2729,7 +2729,7 @@
           <a:bodyPr/>
           <a:lstStyle/>
           <a:p>
-            <a:endParaRPr lang="en-US"/>
+            <a:endParaRPr lang="ja-JP"/>
           </a:p>
         </p:txBody>
       </p:sp>
@@ -2749,10 +2749,10 @@
           <a:lstStyle/>
           <a:p>
             <a:fld id="{C1FF6DA9-008F-8B48-92A6-B652298478BF}" type="slidenum">
-              <a:rPr lang="en-US" smtClean="0"/>
+              <a:rPr lang="ja-JP" smtClean="0"/>
               <a:t>‹#›</a:t>
             </a:fld>
-            <a:endParaRPr lang="en-US"/>
+            <a:endParaRPr lang="ja-JP"/>
           </a:p>
         </p:txBody>
       </p:sp>
@@ -2802,10 +2802,10 @@
           <a:lstStyle/>
           <a:p>
             <a:r>
-              <a:rPr lang="en-US" smtClean="0"/>
+              <a:rPr lang="ja-JP" smtClean="0"/>
               <a:t>Click to edit Master title style</a:t>
             </a:r>
-            <a:endParaRPr lang="en-US"/>
+            <a:endParaRPr lang="ja-JP"/>
           </a:p>
         </p:txBody>
       </p:sp>
@@ -2825,10 +2825,10 @@
           <a:lstStyle/>
           <a:p>
             <a:fld id="{5BCAD085-E8A6-8845-BD4E-CB4CCA059FC4}" type="datetimeFigureOut">
-              <a:rPr lang="en-US" smtClean="0"/>
+              <a:rPr lang="ja-JP" smtClean="0"/>
               <a:t>1/27/13</a:t>
             </a:fld>
-            <a:endParaRPr lang="en-US"/>
+            <a:endParaRPr lang="ja-JP"/>
           </a:p>
         </p:txBody>
       </p:sp>
@@ -2847,7 +2847,7 @@
           <a:bodyPr/>
           <a:lstStyle/>
           <a:p>
-            <a:endParaRPr lang="en-US"/>
+            <a:endParaRPr lang="ja-JP"/>
           </a:p>
         </p:txBody>
       </p:sp>
@@ -2867,10 +2867,10 @@
           <a:lstStyle/>
           <a:p>
             <a:fld id="{C1FF6DA9-008F-8B48-92A6-B652298478BF}" type="slidenum">
-              <a:rPr lang="en-US" smtClean="0"/>
+              <a:rPr lang="ja-JP" smtClean="0"/>
               <a:t>‹#›</a:t>
             </a:fld>
-            <a:endParaRPr lang="en-US"/>
+            <a:endParaRPr lang="ja-JP"/>
           </a:p>
         </p:txBody>
       </p:sp>
@@ -2920,10 +2920,10 @@
           <a:lstStyle/>
           <a:p>
             <a:fld id="{5BCAD085-E8A6-8845-BD4E-CB4CCA059FC4}" type="datetimeFigureOut">
-              <a:rPr lang="en-US" smtClean="0"/>
+              <a:rPr lang="ja-JP" smtClean="0"/>
               <a:t>1/27/13</a:t>
             </a:fld>
-            <a:endParaRPr lang="en-US"/>
+            <a:endParaRPr lang="ja-JP"/>
           </a:p>
         </p:txBody>
       </p:sp>
@@ -2942,7 +2942,7 @@
           <a:bodyPr/>
           <a:lstStyle/>
           <a:p>
-            <a:endParaRPr lang="en-US"/>
+            <a:endParaRPr lang="ja-JP"/>
           </a:p>
         </p:txBody>
       </p:sp>
@@ -2962,10 +2962,10 @@
           <a:lstStyle/>
           <a:p>
             <a:fld id="{C1FF6DA9-008F-8B48-92A6-B652298478BF}" type="slidenum">
-              <a:rPr lang="en-US" smtClean="0"/>
+              <a:rPr lang="ja-JP" smtClean="0"/>
               <a:t>‹#›</a:t>
             </a:fld>
-            <a:endParaRPr lang="en-US"/>
+            <a:endParaRPr lang="ja-JP"/>
           </a:p>
         </p:txBody>
       </p:sp>
@@ -3019,15 +3019,15 @@
           <a:bodyPr anchor="b"/>
           <a:lstStyle>
             <a:lvl1pPr algn="l">
-              <a:defRPr sz="2000" b="1"/>
+              <a:defRPr sz="2000" b="1" lang="ja-JP"/>
             </a:lvl1pPr>
           </a:lstStyle>
           <a:p>
             <a:r>
-              <a:rPr lang="en-US" smtClean="0"/>
+              <a:rPr lang="ja-JP" smtClean="0"/>
               <a:t>Click to edit Master title style</a:t>
             </a:r>
-            <a:endParaRPr lang="en-US"/>
+            <a:endParaRPr lang="ja-JP"/>
           </a:p>
         </p:txBody>
       </p:sp>
@@ -3051,68 +3051,68 @@
           <a:bodyPr/>
           <a:lstStyle>
             <a:lvl1pPr>
-              <a:defRPr sz="3200"/>
+              <a:defRPr sz="3200" lang="ja-JP"/>
             </a:lvl1pPr>
             <a:lvl2pPr>
-              <a:defRPr sz="2800"/>
+              <a:defRPr sz="2800" lang="ja-JP"/>
             </a:lvl2pPr>
             <a:lvl3pPr>
-              <a:defRPr sz="2400"/>
+              <a:defRPr sz="2400" lang="ja-JP"/>
             </a:lvl3pPr>
             <a:lvl4pPr>
-              <a:defRPr sz="2000"/>
+              <a:defRPr sz="2000" lang="ja-JP"/>
             </a:lvl4pPr>
             <a:lvl5pPr>
-              <a:defRPr sz="2000"/>
+              <a:defRPr sz="2000" lang="ja-JP"/>
             </a:lvl5pPr>
             <a:lvl6pPr>
-              <a:defRPr sz="2000"/>
+              <a:defRPr sz="2000" lang="ja-JP"/>
             </a:lvl6pPr>
             <a:lvl7pPr>
-              <a:defRPr sz="2000"/>
+              <a:defRPr sz="2000" lang="ja-JP"/>
             </a:lvl7pPr>
             <a:lvl8pPr>
-              <a:defRPr sz="2000"/>
+              <a:defRPr sz="2000" lang="ja-JP"/>
             </a:lvl8pPr>
             <a:lvl9pPr>
-              <a:defRPr sz="2000"/>
+              <a:defRPr sz="2000" lang="ja-JP"/>
             </a:lvl9pPr>
           </a:lstStyle>
           <a:p>
             <a:pPr lvl="0"/>
             <a:r>
-              <a:rPr lang="en-US" smtClean="0"/>
+              <a:rPr lang="ja-JP" smtClean="0"/>
               <a:t>Click to edit Master text styles</a:t>
             </a:r>
           </a:p>
           <a:p>
             <a:pPr lvl="1"/>
             <a:r>
-              <a:rPr lang="en-US" smtClean="0"/>
+              <a:rPr lang="ja-JP" smtClean="0"/>
               <a:t>Second level</a:t>
             </a:r>
           </a:p>
           <a:p>
             <a:pPr lvl="2"/>
             <a:r>
-              <a:rPr lang="en-US" smtClean="0"/>
+              <a:rPr lang="ja-JP" smtClean="0"/>
               <a:t>Third level</a:t>
             </a:r>
           </a:p>
           <a:p>
             <a:pPr lvl="3"/>
             <a:r>
-              <a:rPr lang="en-US" smtClean="0"/>
+              <a:rPr lang="ja-JP" smtClean="0"/>
               <a:t>Fourth level</a:t>
             </a:r>
           </a:p>
           <a:p>
             <a:pPr lvl="4"/>
             <a:r>
-              <a:rPr lang="en-US" smtClean="0"/>
+              <a:rPr lang="ja-JP" smtClean="0"/>
               <a:t>Fifth level</a:t>
             </a:r>
-            <a:endParaRPr lang="en-US"/>
+            <a:endParaRPr lang="ja-JP"/>
           </a:p>
         </p:txBody>
       </p:sp>
@@ -3137,45 +3137,45 @@
           <a:lstStyle>
             <a:lvl1pPr marL="0" indent="0">
               <a:buNone/>
-              <a:defRPr sz="1400"/>
+              <a:defRPr sz="1400" lang="ja-JP"/>
             </a:lvl1pPr>
             <a:lvl2pPr marL="457200" indent="0">
               <a:buNone/>
-              <a:defRPr sz="1200"/>
+              <a:defRPr sz="1200" lang="ja-JP"/>
             </a:lvl2pPr>
             <a:lvl3pPr marL="914400" indent="0">
               <a:buNone/>
-              <a:defRPr sz="1000"/>
+              <a:defRPr sz="1000" lang="ja-JP"/>
             </a:lvl3pPr>
             <a:lvl4pPr marL="1371600" indent="0">
               <a:buNone/>
-              <a:defRPr sz="900"/>
+              <a:defRPr sz="900" lang="ja-JP"/>
             </a:lvl4pPr>
             <a:lvl5pPr marL="1828800" indent="0">
               <a:buNone/>
-              <a:defRPr sz="900"/>
+              <a:defRPr sz="900" lang="ja-JP"/>
             </a:lvl5pPr>
             <a:lvl6pPr marL="2286000" indent="0">
               <a:buNone/>
-              <a:defRPr sz="900"/>
+              <a:defRPr sz="900" lang="ja-JP"/>
             </a:lvl6pPr>
             <a:lvl7pPr marL="2743200" indent="0">
               <a:buNone/>
-              <a:defRPr sz="900"/>
+              <a:defRPr sz="900" lang="ja-JP"/>
             </a:lvl7pPr>
             <a:lvl8pPr marL="3200400" indent="0">
               <a:buNone/>
-              <a:defRPr sz="900"/>
+              <a:defRPr sz="900" lang="ja-JP"/>
             </a:lvl8pPr>
             <a:lvl9pPr marL="3657600" indent="0">
               <a:buNone/>
-              <a:defRPr sz="900"/>
+              <a:defRPr sz="900" lang="ja-JP"/>
             </a:lvl9pPr>
           </a:lstStyle>
           <a:p>
             <a:pPr lvl="0"/>
             <a:r>
-              <a:rPr lang="en-US" smtClean="0"/>
+              <a:rPr lang="ja-JP" smtClean="0"/>
               <a:t>Click to edit Master text styles</a:t>
             </a:r>
           </a:p>
@@ -3197,10 +3197,10 @@
           <a:lstStyle/>
           <a:p>
             <a:fld id="{5BCAD085-E8A6-8845-BD4E-CB4CCA059FC4}" type="datetimeFigureOut">
-              <a:rPr lang="en-US" smtClean="0"/>
+              <a:rPr lang="ja-JP" smtClean="0"/>
               <a:t>1/27/13</a:t>
             </a:fld>
-            <a:endParaRPr lang="en-US"/>
+            <a:endParaRPr lang="ja-JP"/>
           </a:p>
         </p:txBody>
       </p:sp>
@@ -3219,7 +3219,7 @@
           <a:bodyPr/>
           <a:lstStyle/>
           <a:p>
-            <a:endParaRPr lang="en-US"/>
+            <a:endParaRPr lang="ja-JP"/>
           </a:p>
         </p:txBody>
       </p:sp>
@@ -3239,10 +3239,10 @@
           <a:lstStyle/>
           <a:p>
             <a:fld id="{C1FF6DA9-008F-8B48-92A6-B652298478BF}" type="slidenum">
-              <a:rPr lang="en-US" smtClean="0"/>
+              <a:rPr lang="ja-JP" smtClean="0"/>
               <a:t>‹#›</a:t>
             </a:fld>
-            <a:endParaRPr lang="en-US"/>
+            <a:endParaRPr lang="ja-JP"/>
           </a:p>
         </p:txBody>
       </p:sp>
@@ -3296,15 +3296,15 @@
           <a:bodyPr anchor="b"/>
           <a:lstStyle>
             <a:lvl1pPr algn="l">
-              <a:defRPr sz="2000" b="1"/>
+              <a:defRPr sz="2000" b="1" lang="ja-JP"/>
             </a:lvl1pPr>
           </a:lstStyle>
           <a:p>
             <a:r>
-              <a:rPr lang="en-US" smtClean="0"/>
+              <a:rPr lang="ja-JP" smtClean="0"/>
               <a:t>Click to edit Master title style</a:t>
             </a:r>
-            <a:endParaRPr lang="en-US"/>
+            <a:endParaRPr lang="ja-JP"/>
           </a:p>
         </p:txBody>
       </p:sp>
@@ -3329,43 +3329,43 @@
           <a:lstStyle>
             <a:lvl1pPr marL="0" indent="0">
               <a:buNone/>
-              <a:defRPr sz="3200"/>
+              <a:defRPr sz="3200" lang="ja-JP"/>
             </a:lvl1pPr>
             <a:lvl2pPr marL="457200" indent="0">
               <a:buNone/>
-              <a:defRPr sz="2800"/>
+              <a:defRPr sz="2800" lang="ja-JP"/>
             </a:lvl2pPr>
             <a:lvl3pPr marL="914400" indent="0">
               <a:buNone/>
-              <a:defRPr sz="2400"/>
+              <a:defRPr sz="2400" lang="ja-JP"/>
             </a:lvl3pPr>
             <a:lvl4pPr marL="1371600" indent="0">
               <a:buNone/>
-              <a:defRPr sz="2000"/>
+              <a:defRPr sz="2000" lang="ja-JP"/>
             </a:lvl4pPr>
             <a:lvl5pPr marL="1828800" indent="0">
               <a:buNone/>
-              <a:defRPr sz="2000"/>
+              <a:defRPr sz="2000" lang="ja-JP"/>
             </a:lvl5pPr>
             <a:lvl6pPr marL="2286000" indent="0">
               <a:buNone/>
-              <a:defRPr sz="2000"/>
+              <a:defRPr sz="2000" lang="ja-JP"/>
             </a:lvl6pPr>
             <a:lvl7pPr marL="2743200" indent="0">
               <a:buNone/>
-              <a:defRPr sz="2000"/>
+              <a:defRPr sz="2000" lang="ja-JP"/>
             </a:lvl7pPr>
             <a:lvl8pPr marL="3200400" indent="0">
               <a:buNone/>
-              <a:defRPr sz="2000"/>
+              <a:defRPr sz="2000" lang="ja-JP"/>
             </a:lvl8pPr>
             <a:lvl9pPr marL="3657600" indent="0">
               <a:buNone/>
-              <a:defRPr sz="2000"/>
+              <a:defRPr sz="2000" lang="ja-JP"/>
             </a:lvl9pPr>
           </a:lstStyle>
           <a:p>
-            <a:endParaRPr lang="en-US"/>
+            <a:endParaRPr lang="ja-JP"/>
           </a:p>
         </p:txBody>
       </p:sp>
@@ -3390,45 +3390,45 @@
           <a:lstStyle>
             <a:lvl1pPr marL="0" indent="0">
               <a:buNone/>
-              <a:defRPr sz="1400"/>
+              <a:defRPr sz="1400" lang="ja-JP"/>
             </a:lvl1pPr>
             <a:lvl2pPr marL="457200" indent="0">
               <a:buNone/>
-              <a:defRPr sz="1200"/>
+              <a:defRPr sz="1200" lang="ja-JP"/>
             </a:lvl2pPr>
             <a:lvl3pPr marL="914400" indent="0">
               <a:buNone/>
-              <a:defRPr sz="1000"/>
+              <a:defRPr sz="1000" lang="ja-JP"/>
             </a:lvl3pPr>
             <a:lvl4pPr marL="1371600" indent="0">
               <a:buNone/>
-              <a:defRPr sz="900"/>
+              <a:defRPr sz="900" lang="ja-JP"/>
             </a:lvl4pPr>
             <a:lvl5pPr marL="1828800" indent="0">
               <a:buNone/>
-              <a:defRPr sz="900"/>
+              <a:defRPr sz="900" lang="ja-JP"/>
             </a:lvl5pPr>
             <a:lvl6pPr marL="2286000" indent="0">
               <a:buNone/>
-              <a:defRPr sz="900"/>
+              <a:defRPr sz="900" lang="ja-JP"/>
             </a:lvl6pPr>
             <a:lvl7pPr marL="2743200" indent="0">
               <a:buNone/>
-              <a:defRPr sz="900"/>
+              <a:defRPr sz="900" lang="ja-JP"/>
             </a:lvl7pPr>
             <a:lvl8pPr marL="3200400" indent="0">
               <a:buNone/>
-              <a:defRPr sz="900"/>
+              <a:defRPr sz="900" lang="ja-JP"/>
             </a:lvl8pPr>
             <a:lvl9pPr marL="3657600" indent="0">
               <a:buNone/>
-              <a:defRPr sz="900"/>
+              <a:defRPr sz="900" lang="ja-JP"/>
             </a:lvl9pPr>
           </a:lstStyle>
           <a:p>
             <a:pPr lvl="0"/>
             <a:r>
-              <a:rPr lang="en-US" smtClean="0"/>
+              <a:rPr lang="ja-JP" smtClean="0"/>
               <a:t>Click to edit Master text styles</a:t>
             </a:r>
           </a:p>
@@ -3450,10 +3450,10 @@
           <a:lstStyle/>
           <a:p>
             <a:fld id="{5BCAD085-E8A6-8845-BD4E-CB4CCA059FC4}" type="datetimeFigureOut">
-              <a:rPr lang="en-US" smtClean="0"/>
+              <a:rPr lang="ja-JP" smtClean="0"/>
               <a:t>1/27/13</a:t>
             </a:fld>
-            <a:endParaRPr lang="en-US"/>
+            <a:endParaRPr lang="ja-JP"/>
           </a:p>
         </p:txBody>
       </p:sp>
@@ -3472,7 +3472,7 @@
           <a:bodyPr/>
           <a:lstStyle/>
           <a:p>
-            <a:endParaRPr lang="en-US"/>
+            <a:endParaRPr lang="ja-JP"/>
           </a:p>
         </p:txBody>
       </p:sp>
@@ -3492,10 +3492,10 @@
           <a:lstStyle/>
           <a:p>
             <a:fld id="{C1FF6DA9-008F-8B48-92A6-B652298478BF}" type="slidenum">
-              <a:rPr lang="en-US" smtClean="0"/>
+              <a:rPr lang="ja-JP" smtClean="0"/>
               <a:t>‹#›</a:t>
             </a:fld>
-            <a:endParaRPr lang="en-US"/>
+            <a:endParaRPr lang="ja-JP"/>
           </a:p>
         </p:txBody>
       </p:sp>
@@ -3560,10 +3560,10 @@
           <a:lstStyle/>
           <a:p>
             <a:r>
-              <a:rPr lang="en-US" smtClean="0"/>
+              <a:rPr lang="ja-JP" smtClean="0"/>
               <a:t>Click to edit Master title style</a:t>
             </a:r>
-            <a:endParaRPr lang="en-US"/>
+            <a:endParaRPr lang="ja-JP"/>
           </a:p>
         </p:txBody>
       </p:sp>
@@ -3594,38 +3594,38 @@
           <a:p>
             <a:pPr lvl="0"/>
             <a:r>
-              <a:rPr lang="en-US" smtClean="0"/>
+              <a:rPr lang="ja-JP" smtClean="0"/>
               <a:t>Click to edit Master text styles</a:t>
             </a:r>
           </a:p>
           <a:p>
             <a:pPr lvl="1"/>
             <a:r>
-              <a:rPr lang="en-US" smtClean="0"/>
+              <a:rPr lang="ja-JP" smtClean="0"/>
               <a:t>Second level</a:t>
             </a:r>
           </a:p>
           <a:p>
             <a:pPr lvl="2"/>
             <a:r>
-              <a:rPr lang="en-US" smtClean="0"/>
+              <a:rPr lang="ja-JP" smtClean="0"/>
               <a:t>Third level</a:t>
             </a:r>
           </a:p>
           <a:p>
             <a:pPr lvl="3"/>
             <a:r>
-              <a:rPr lang="en-US" smtClean="0"/>
+              <a:rPr lang="ja-JP" smtClean="0"/>
               <a:t>Fourth level</a:t>
             </a:r>
           </a:p>
           <a:p>
             <a:pPr lvl="4"/>
             <a:r>
-              <a:rPr lang="en-US" smtClean="0"/>
+              <a:rPr lang="ja-JP" smtClean="0"/>
               <a:t>Fifth level</a:t>
             </a:r>
-            <a:endParaRPr lang="en-US"/>
+            <a:endParaRPr lang="ja-JP"/>
           </a:p>
         </p:txBody>
       </p:sp>
@@ -3652,7 +3652,7 @@
           <a:bodyPr vert="horz" lIns="91440" tIns="45720" rIns="91440" bIns="45720" rtlCol="0" anchor="ctr"/>
           <a:lstStyle>
             <a:lvl1pPr algn="l">
-              <a:defRPr sz="1200">
+              <a:defRPr sz="1200" lang="ja-JP">
                 <a:solidFill>
                   <a:schemeClr val="tx1">
                     <a:tint val="75000"/>
@@ -3663,10 +3663,10 @@
           </a:lstStyle>
           <a:p>
             <a:fld id="{5BCAD085-E8A6-8845-BD4E-CB4CCA059FC4}" type="datetimeFigureOut">
-              <a:rPr lang="en-US" smtClean="0"/>
+              <a:rPr lang="ja-JP" smtClean="0"/>
               <a:t>1/27/13</a:t>
             </a:fld>
-            <a:endParaRPr lang="en-US"/>
+            <a:endParaRPr lang="ja-JP"/>
           </a:p>
         </p:txBody>
       </p:sp>
@@ -3693,7 +3693,7 @@
           <a:bodyPr vert="horz" lIns="91440" tIns="45720" rIns="91440" bIns="45720" rtlCol="0" anchor="ctr"/>
           <a:lstStyle>
             <a:lvl1pPr algn="ctr">
-              <a:defRPr sz="1200">
+              <a:defRPr sz="1200" lang="ja-JP">
                 <a:solidFill>
                   <a:schemeClr val="tx1">
                     <a:tint val="75000"/>
@@ -3703,7 +3703,7 @@
             </a:lvl1pPr>
           </a:lstStyle>
           <a:p>
-            <a:endParaRPr lang="en-US"/>
+            <a:endParaRPr lang="ja-JP"/>
           </a:p>
         </p:txBody>
       </p:sp>
@@ -3730,7 +3730,7 @@
           <a:bodyPr vert="horz" lIns="91440" tIns="45720" rIns="91440" bIns="45720" rtlCol="0" anchor="ctr"/>
           <a:lstStyle>
             <a:lvl1pPr algn="r">
-              <a:defRPr sz="1200">
+              <a:defRPr sz="1200" lang="ja-JP">
                 <a:solidFill>
                   <a:schemeClr val="tx1">
                     <a:tint val="75000"/>
@@ -3741,10 +3741,10 @@
           </a:lstStyle>
           <a:p>
             <a:fld id="{C1FF6DA9-008F-8B48-92A6-B652298478BF}" type="slidenum">
-              <a:rPr lang="en-US" smtClean="0"/>
+              <a:rPr lang="ja-JP" smtClean="0"/>
               <a:t>‹#›</a:t>
             </a:fld>
-            <a:endParaRPr lang="en-US"/>
+            <a:endParaRPr lang="ja-JP"/>
           </a:p>
         </p:txBody>
       </p:sp>
@@ -3776,7 +3776,7 @@
           <a:spcPct val="0"/>
         </a:spcBef>
         <a:buNone/>
-        <a:defRPr sz="4400" kern="1200">
+        <a:defRPr sz="4400" kern="1200" lang="ja-JP">
           <a:solidFill>
             <a:schemeClr val="tx1"/>
           </a:solidFill>
@@ -3793,7 +3793,7 @@
         </a:spcBef>
         <a:buFont typeface="Arial"/>
         <a:buChar char="•"/>
-        <a:defRPr sz="3200" kern="1200">
+        <a:defRPr sz="3200" kern="1200" lang="ja-JP">
           <a:solidFill>
             <a:schemeClr val="tx1"/>
           </a:solidFill>
@@ -3808,7 +3808,7 @@
         </a:spcBef>
         <a:buFont typeface="Arial"/>
         <a:buChar char="–"/>
-        <a:defRPr sz="2800" kern="1200">
+        <a:defRPr sz="2800" kern="1200" lang="ja-JP">
           <a:solidFill>
             <a:schemeClr val="tx1"/>
           </a:solidFill>
@@ -3823,7 +3823,7 @@
         </a:spcBef>
         <a:buFont typeface="Arial"/>
         <a:buChar char="•"/>
-        <a:defRPr sz="2400" kern="1200">
+        <a:defRPr sz="2400" kern="1200" lang="ja-JP">
           <a:solidFill>
             <a:schemeClr val="tx1"/>
           </a:solidFill>
@@ -3838,7 +3838,7 @@
         </a:spcBef>
         <a:buFont typeface="Arial"/>
         <a:buChar char="–"/>
-        <a:defRPr sz="2000" kern="1200">
+        <a:defRPr sz="2000" kern="1200" lang="ja-JP">
           <a:solidFill>
             <a:schemeClr val="tx1"/>
           </a:solidFill>
@@ -3853,7 +3853,7 @@
         </a:spcBef>
         <a:buFont typeface="Arial"/>
         <a:buChar char="»"/>
-        <a:defRPr sz="2000" kern="1200">
+        <a:defRPr sz="2000" kern="1200" lang="ja-JP">
           <a:solidFill>
             <a:schemeClr val="tx1"/>
           </a:solidFill>
@@ -3868,7 +3868,7 @@
         </a:spcBef>
         <a:buFont typeface="Arial"/>
         <a:buChar char="•"/>
-        <a:defRPr sz="2000" kern="1200">
+        <a:defRPr sz="2000" kern="1200" lang="ja-JP">
           <a:solidFill>
             <a:schemeClr val="tx1"/>
           </a:solidFill>
@@ -3883,7 +3883,7 @@
         </a:spcBef>
         <a:buFont typeface="Arial"/>
         <a:buChar char="•"/>
-        <a:defRPr sz="2000" kern="1200">
+        <a:defRPr sz="2000" kern="1200" lang="ja-JP">
           <a:solidFill>
             <a:schemeClr val="tx1"/>
           </a:solidFill>
@@ -3898,7 +3898,7 @@
         </a:spcBef>
         <a:buFont typeface="Arial"/>
         <a:buChar char="•"/>
-        <a:defRPr sz="2000" kern="1200">
+        <a:defRPr sz="2000" kern="1200" lang="ja-JP">
           <a:solidFill>
             <a:schemeClr val="tx1"/>
           </a:solidFill>
@@ -3913,7 +3913,7 @@
         </a:spcBef>
         <a:buFont typeface="Arial"/>
         <a:buChar char="•"/>
-        <a:defRPr sz="2000" kern="1200">
+        <a:defRPr sz="2000" kern="1200" lang="ja-JP">
           <a:solidFill>
             <a:schemeClr val="tx1"/>
           </a:solidFill>
@@ -3925,10 +3925,10 @@
     </p:bodyStyle>
     <p:otherStyle>
       <a:defPPr>
-        <a:defRPr lang="en-US"/>
+        <a:defRPr lang="ja-JP"/>
       </a:defPPr>
       <a:lvl1pPr marL="0" algn="l" defTabSz="457200" rtl="0" eaLnBrk="1" latinLnBrk="0" hangingPunct="1">
-        <a:defRPr sz="1800" kern="1200">
+        <a:defRPr sz="1800" kern="1200" lang="ja-JP">
           <a:solidFill>
             <a:schemeClr val="tx1"/>
           </a:solidFill>
@@ -3938,7 +3938,7 @@
         </a:defRPr>
       </a:lvl1pPr>
       <a:lvl2pPr marL="457200" algn="l" defTabSz="457200" rtl="0" eaLnBrk="1" latinLnBrk="0" hangingPunct="1">
-        <a:defRPr sz="1800" kern="1200">
+        <a:defRPr sz="1800" kern="1200" lang="ja-JP">
           <a:solidFill>
             <a:schemeClr val="tx1"/>
           </a:solidFill>
@@ -3948,7 +3948,7 @@
         </a:defRPr>
       </a:lvl2pPr>
       <a:lvl3pPr marL="914400" algn="l" defTabSz="457200" rtl="0" eaLnBrk="1" latinLnBrk="0" hangingPunct="1">
-        <a:defRPr sz="1800" kern="1200">
+        <a:defRPr sz="1800" kern="1200" lang="ja-JP">
           <a:solidFill>
             <a:schemeClr val="tx1"/>
           </a:solidFill>
@@ -3958,7 +3958,7 @@
         </a:defRPr>
       </a:lvl3pPr>
       <a:lvl4pPr marL="1371600" algn="l" defTabSz="457200" rtl="0" eaLnBrk="1" latinLnBrk="0" hangingPunct="1">
-        <a:defRPr sz="1800" kern="1200">
+        <a:defRPr sz="1800" kern="1200" lang="ja-JP">
           <a:solidFill>
             <a:schemeClr val="tx1"/>
           </a:solidFill>
@@ -3968,7 +3968,7 @@
         </a:defRPr>
       </a:lvl4pPr>
       <a:lvl5pPr marL="1828800" algn="l" defTabSz="457200" rtl="0" eaLnBrk="1" latinLnBrk="0" hangingPunct="1">
-        <a:defRPr sz="1800" kern="1200">
+        <a:defRPr sz="1800" kern="1200" lang="ja-JP">
           <a:solidFill>
             <a:schemeClr val="tx1"/>
           </a:solidFill>
@@ -3978,7 +3978,7 @@
         </a:defRPr>
       </a:lvl5pPr>
       <a:lvl6pPr marL="2286000" algn="l" defTabSz="457200" rtl="0" eaLnBrk="1" latinLnBrk="0" hangingPunct="1">
-        <a:defRPr sz="1800" kern="1200">
+        <a:defRPr sz="1800" kern="1200" lang="ja-JP">
           <a:solidFill>
             <a:schemeClr val="tx1"/>
           </a:solidFill>
@@ -3988,7 +3988,7 @@
         </a:defRPr>
       </a:lvl6pPr>
       <a:lvl7pPr marL="2743200" algn="l" defTabSz="457200" rtl="0" eaLnBrk="1" latinLnBrk="0" hangingPunct="1">
-        <a:defRPr sz="1800" kern="1200">
+        <a:defRPr sz="1800" kern="1200" lang="ja-JP">
           <a:solidFill>
             <a:schemeClr val="tx1"/>
           </a:solidFill>
@@ -3998,7 +3998,7 @@
         </a:defRPr>
       </a:lvl7pPr>
       <a:lvl8pPr marL="3200400" algn="l" defTabSz="457200" rtl="0" eaLnBrk="1" latinLnBrk="0" hangingPunct="1">
-        <a:defRPr sz="1800" kern="1200">
+        <a:defRPr sz="1800" kern="1200" lang="ja-JP">
           <a:solidFill>
             <a:schemeClr val="tx1"/>
           </a:solidFill>
@@ -4008,7 +4008,7 @@
         </a:defRPr>
       </a:lvl8pPr>
       <a:lvl9pPr marL="3657600" algn="l" defTabSz="457200" rtl="0" eaLnBrk="1" latinLnBrk="0" hangingPunct="1">
-        <a:defRPr sz="1800" kern="1200">
+        <a:defRPr sz="1800" kern="1200" lang="ja-JP">
           <a:solidFill>
             <a:schemeClr val="tx1"/>
           </a:solidFill>
@@ -4062,7 +4062,7 @@
               <a:buNone/>
             </a:pPr>
             <a:r>
-              <a:rPr sz="6800" b="1" i="0">
+              <a:rPr sz="6800" b="1" i="0" lang="ja-JP">
                 <a:solidFill>
                   <a:srgbClr val="000000"/>
                 </a:solidFill>
@@ -4105,7 +4105,7 @@
               <a:buNone/>
             </a:pPr>
             <a:r>
-              <a:rPr sz="3200" b="0" i="0">
+              <a:rPr sz="3200" b="0" i="0" lang="ja-JP">
                 <a:solidFill>
                   <a:srgbClr val="404040"/>
                 </a:solidFill>
@@ -4148,7 +4148,7 @@
               <a:buNone/>
             </a:pPr>
             <a:r>
-              <a:rPr sz="3800" b="1" i="0">
+              <a:rPr sz="3800" b="1" i="0" lang="ja-JP">
                 <a:solidFill>
                   <a:srgbClr val="000000"/>
                 </a:solidFill>
@@ -4159,7 +4159,7 @@
               <a:t>中野 友晴</a:t>
             </a:r>
             <a:r>
-              <a:rPr sz="3800" b="0" i="0">
+              <a:rPr sz="3800" b="0" i="0" lang="ja-JP">
                 <a:solidFill>
                   <a:srgbClr val="000000"/>
                 </a:solidFill>
@@ -4288,7 +4288,7 @@
               <a:buNone/>
             </a:pPr>
             <a:r>
-              <a:rPr sz="4800" b="1" i="0">
+              <a:rPr sz="4800" b="1" i="0" lang="ja-JP">
                 <a:solidFill>
                   <a:srgbClr val="FFFFFF"/>
                 </a:solidFill>
@@ -4377,7 +4377,7 @@
               <a:buNone/>
             </a:pPr>
             <a:r>
-              <a:rPr sz="3600" b="1" i="0">
+              <a:rPr sz="3600" b="1" i="0" lang="ja-JP">
                 <a:solidFill>
                   <a:srgbClr val="000000"/>
                 </a:solidFill>
@@ -4466,7 +4466,7 @@
               <a:buNone/>
             </a:pPr>
             <a:r>
-              <a:rPr sz="3200" b="1" i="0">
+              <a:rPr sz="3200" b="1" i="0" lang="ja-JP">
                 <a:solidFill>
                   <a:srgbClr val="70AD47"/>
                 </a:solidFill>
@@ -4477,7 +4477,7 @@
               <a:t>① </a:t>
             </a:r>
             <a:r>
-              <a:rPr sz="3200" b="1" i="0">
+              <a:rPr sz="3200" b="1" i="0" lang="ja-JP">
                 <a:solidFill>
                   <a:srgbClr val="000000"/>
                 </a:solidFill>
@@ -4499,7 +4499,7 @@
               <a:buNone/>
             </a:pPr>
             <a:r>
-              <a:rPr sz="3800" b="1" i="0">
+              <a:rPr sz="3800" b="1" i="0" lang="ja-JP">
                 <a:solidFill>
                   <a:srgbClr val="C00000"/>
                 </a:solidFill>
@@ -4588,7 +4588,7 @@
               <a:buNone/>
             </a:pPr>
             <a:r>
-              <a:rPr sz="3200" b="1" i="0">
+              <a:rPr sz="3200" b="1" i="0" lang="ja-JP">
                 <a:solidFill>
                   <a:srgbClr val="70AD47"/>
                 </a:solidFill>
@@ -4599,7 +4599,7 @@
               <a:t>② </a:t>
             </a:r>
             <a:r>
-              <a:rPr sz="3200" b="1" i="0">
+              <a:rPr sz="3200" b="1" i="0" lang="ja-JP">
                 <a:solidFill>
                   <a:srgbClr val="000000"/>
                 </a:solidFill>
@@ -4621,7 +4621,7 @@
               <a:buNone/>
             </a:pPr>
             <a:r>
-              <a:rPr sz="3800" b="1" i="0">
+              <a:rPr sz="3800" b="1" i="0" lang="ja-JP">
                 <a:solidFill>
                   <a:srgbClr val="000000"/>
                 </a:solidFill>
@@ -4710,7 +4710,7 @@
               <a:buNone/>
             </a:pPr>
             <a:r>
-              <a:rPr sz="3200" b="1" i="0">
+              <a:rPr sz="3200" b="1" i="0" lang="ja-JP">
                 <a:solidFill>
                   <a:srgbClr val="70AD47"/>
                 </a:solidFill>
@@ -4721,7 +4721,7 @@
               <a:t>③ </a:t>
             </a:r>
             <a:r>
-              <a:rPr sz="3200" b="1" i="0">
+              <a:rPr sz="3200" b="1" i="0" lang="ja-JP">
                 <a:solidFill>
                   <a:srgbClr val="000000"/>
                 </a:solidFill>
@@ -4743,7 +4743,7 @@
               <a:buNone/>
             </a:pPr>
             <a:r>
-              <a:rPr sz="3800" b="1" i="0">
+              <a:rPr sz="3800" b="1" i="0" lang="ja-JP">
                 <a:solidFill>
                   <a:srgbClr val="C00000"/>
                 </a:solidFill>
@@ -4828,7 +4828,7 @@
               <a:buNone/>
             </a:pPr>
             <a:r>
-              <a:rPr sz="4000" b="1" i="0">
+              <a:rPr sz="4000" b="1" i="0" lang="ja-JP">
                 <a:solidFill>
                   <a:srgbClr val="FFFFFF"/>
                 </a:solidFill>
@@ -4871,7 +4871,7 @@
               <a:buNone/>
             </a:pPr>
             <a:r>
-              <a:rPr sz="3600" b="0" i="0">
+              <a:rPr sz="3600" b="0" i="0" lang="ja-JP">
                 <a:solidFill>
                   <a:srgbClr val="000000"/>
                 </a:solidFill>
@@ -4893,7 +4893,7 @@
               <a:buNone/>
             </a:pPr>
             <a:r>
-              <a:rPr sz="3600" b="1" i="0">
+              <a:rPr sz="3600" b="1" i="0" lang="ja-JP">
                 <a:solidFill>
                   <a:srgbClr val="000000"/>
                 </a:solidFill>
@@ -4904,7 +4904,7 @@
               <a:t>Waniら[1]　</a:t>
             </a:r>
             <a:r>
-              <a:rPr sz="3600" b="0" i="0">
+              <a:rPr sz="3600" b="0" i="0" lang="ja-JP">
                 <a:solidFill>
                   <a:srgbClr val="000000"/>
                 </a:solidFill>
@@ -4926,7 +4926,7 @@
               <a:buNone/>
             </a:pPr>
             <a:r>
-              <a:rPr sz="3600" b="0" i="0">
+              <a:rPr sz="3600" b="0" i="0" lang="ja-JP">
                 <a:solidFill>
                   <a:srgbClr val="000000"/>
                 </a:solidFill>
@@ -5015,7 +5015,7 @@
               <a:buNone/>
             </a:pPr>
             <a:r>
-              <a:rPr sz="3600" b="1" i="0">
+              <a:rPr sz="3600" b="1" i="0" lang="ja-JP">
                 <a:solidFill>
                   <a:srgbClr val="70AD47"/>
                 </a:solidFill>
@@ -5026,7 +5026,7 @@
               <a:t>仮説　</a:t>
             </a:r>
             <a:r>
-              <a:rPr sz="3600" b="1" i="0">
+              <a:rPr sz="3600" b="1" i="0" lang="ja-JP">
                 <a:solidFill>
                   <a:srgbClr val="000000"/>
                 </a:solidFill>
@@ -5111,7 +5111,7 @@
               <a:buNone/>
             </a:pPr>
             <a:r>
-              <a:rPr sz="4000" b="1" i="0">
+              <a:rPr sz="4000" b="1" i="0" lang="ja-JP">
                 <a:solidFill>
                   <a:srgbClr val="FFFFFF"/>
                 </a:solidFill>
@@ -5178,7 +5178,7 @@
               <a:buNone/>
             </a:pPr>
             <a:r>
-              <a:rPr sz="2600" b="0" i="0">
+              <a:rPr sz="2600" b="0" i="0" lang="ja-JP">
                 <a:solidFill>
                   <a:srgbClr val="000000"/>
                 </a:solidFill>
@@ -5221,7 +5221,7 @@
               <a:buNone/>
             </a:pPr>
             <a:r>
-              <a:rPr sz="3600" b="1" i="0">
+              <a:rPr sz="3600" b="1" i="0" lang="ja-JP">
                 <a:solidFill>
                   <a:srgbClr val="000000"/>
                 </a:solidFill>
@@ -5232,7 +5232,7 @@
               <a:t>タスク署名　</a:t>
             </a:r>
             <a:r>
-              <a:rPr sz="3600" b="0" i="0">
+              <a:rPr sz="3600" b="0" i="0" lang="ja-JP">
                 <a:solidFill>
                   <a:srgbClr val="000000"/>
                 </a:solidFill>
@@ -5283,7 +5283,7 @@
                         <a:buNone/>
                       </a:pPr>
                       <a:r>
-                        <a:rPr sz="3000" b="1" i="0">
+                        <a:rPr sz="3000" b="1" i="0" lang="ja-JP">
                           <a:solidFill>
                             <a:srgbClr val="FFFFFF"/>
                           </a:solidFill>
@@ -5316,7 +5316,7 @@
                         <a:buNone/>
                       </a:pPr>
                       <a:r>
-                        <a:rPr sz="3000" b="1" i="0">
+                        <a:rPr sz="3000" b="1" i="0" lang="ja-JP">
                           <a:solidFill>
                             <a:srgbClr val="FFFFFF"/>
                           </a:solidFill>
@@ -5351,7 +5351,7 @@
                         <a:buNone/>
                       </a:pPr>
                       <a:r>
-                        <a:rPr sz="3000" b="0" i="0">
+                        <a:rPr sz="3000" b="0" i="0" lang="ja-JP">
                           <a:solidFill>
                             <a:srgbClr val="000000"/>
                           </a:solidFill>
@@ -5384,7 +5384,7 @@
                         <a:buNone/>
                       </a:pPr>
                       <a:r>
-                        <a:rPr sz="3000" b="0" i="0">
+                        <a:rPr sz="3000" b="0" i="0" lang="ja-JP">
                           <a:solidFill>
                             <a:srgbClr val="000000"/>
                           </a:solidFill>
@@ -5419,7 +5419,7 @@
                         <a:buNone/>
                       </a:pPr>
                       <a:r>
-                        <a:rPr sz="3000" b="0" i="0">
+                        <a:rPr sz="3000" b="0" i="0" lang="ja-JP">
                           <a:solidFill>
                             <a:srgbClr val="000000"/>
                           </a:solidFill>
@@ -5452,7 +5452,7 @@
                         <a:buNone/>
                       </a:pPr>
                       <a:r>
-                        <a:rPr sz="3000" b="0" i="0">
+                        <a:rPr sz="3000" b="0" i="0" lang="ja-JP">
                           <a:solidFill>
                             <a:srgbClr val="000000"/>
                           </a:solidFill>
@@ -5487,7 +5487,7 @@
                         <a:buNone/>
                       </a:pPr>
                       <a:r>
-                        <a:rPr sz="3000" b="0" i="0">
+                        <a:rPr sz="3000" b="0" i="0" lang="ja-JP">
                           <a:solidFill>
                             <a:srgbClr val="000000"/>
                           </a:solidFill>
@@ -5520,7 +5520,7 @@
                         <a:buNone/>
                       </a:pPr>
                       <a:r>
-                        <a:rPr sz="3000" b="0" i="0">
+                        <a:rPr sz="3000" b="0" i="0" lang="ja-JP">
                           <a:solidFill>
                             <a:srgbClr val="000000"/>
                           </a:solidFill>
@@ -5573,7 +5573,7 @@
               <a:buNone/>
             </a:pPr>
             <a:r>
-              <a:rPr sz="3600" b="1" i="0">
+              <a:rPr sz="3600" b="1" i="0" lang="ja-JP">
                 <a:solidFill>
                   <a:srgbClr val="000000"/>
                 </a:solidFill>
@@ -5584,7 +5584,7 @@
               <a:t>学習　</a:t>
             </a:r>
             <a:r>
-              <a:rPr sz="3600" b="0" i="0">
+              <a:rPr sz="3600" b="0" i="0" lang="ja-JP">
                 <a:solidFill>
                   <a:srgbClr val="000000"/>
                 </a:solidFill>
@@ -5595,7 +5595,7 @@
               <a:t>ℒ = ℒ</a:t>
             </a:r>
             <a:r>
-              <a:rPr sz="2000" b="0" i="0">
+              <a:rPr sz="2000" b="0" i="0" lang="ja-JP">
                 <a:solidFill>
                   <a:srgbClr val="000000"/>
                 </a:solidFill>
@@ -5606,7 +5606,7 @@
               <a:t>LM</a:t>
             </a:r>
             <a:r>
-              <a:rPr sz="3600" b="0" i="0">
+              <a:rPr sz="3600" b="0" i="0" lang="ja-JP">
                 <a:solidFill>
                   <a:srgbClr val="000000"/>
                 </a:solidFill>
@@ -5617,7 +5617,7 @@
               <a:t> + 𝜆ℒ</a:t>
             </a:r>
             <a:r>
-              <a:rPr sz="2000" b="0" i="0">
+              <a:rPr sz="2000" b="0" i="0" lang="ja-JP">
                 <a:solidFill>
                   <a:srgbClr val="000000"/>
                 </a:solidFill>
@@ -5628,7 +5628,7 @@
               <a:t>align</a:t>
             </a:r>
             <a:r>
-              <a:rPr sz="3600" b="0" i="0">
+              <a:rPr sz="3600" b="0" i="0" lang="ja-JP">
                 <a:solidFill>
                   <a:srgbClr val="000000"/>
                 </a:solidFill>
@@ -5639,7 +5639,7 @@
               <a:t>，</a:t>
             </a:r>
             <a:r>
-              <a:rPr sz="3600" b="0" i="0">
+              <a:rPr sz="3600" b="0" i="0" lang="ja-JP">
                 <a:solidFill>
                   <a:srgbClr val="000000"/>
                 </a:solidFill>
@@ -5662,7 +5662,7 @@
               <a:buChar char="•"/>
             </a:pPr>
             <a:r>
-              <a:rPr sz="3000" b="0" i="0">
+              <a:rPr sz="3000" b="0" i="0" lang="ja-JP">
                 <a:solidFill>
                   <a:srgbClr val="000000"/>
                 </a:solidFill>
@@ -5673,7 +5673,7 @@
               <a:t>整合損失</a:t>
             </a:r>
             <a:r>
-              <a:rPr sz="3000" b="0" i="0">
+              <a:rPr sz="3000" b="0" i="0" lang="ja-JP">
                 <a:solidFill>
                   <a:srgbClr val="000000"/>
                 </a:solidFill>
@@ -5684,7 +5684,7 @@
               <a:t>ℒ</a:t>
             </a:r>
             <a:r>
-              <a:rPr sz="2000" b="0" i="0">
+              <a:rPr sz="2000" b="0" i="0" lang="ja-JP">
                 <a:solidFill>
                   <a:srgbClr val="000000"/>
                 </a:solidFill>
@@ -5695,7 +5695,7 @@
               <a:t>align</a:t>
             </a:r>
             <a:r>
-              <a:rPr sz="3000" b="0" i="0">
+              <a:rPr sz="3000" b="0" i="0" lang="ja-JP">
                 <a:solidFill>
                   <a:srgbClr val="000000"/>
                 </a:solidFill>
@@ -5706,7 +5706,7 @@
               <a:t>は，署名をクラスとする supervised contrastive loss[4]．射影を挟まず，第16層・入力末尾の内部表現</a:t>
             </a:r>
             <a:r>
-              <a:rPr sz="3000" b="0" i="0">
+              <a:rPr sz="3000" b="0" i="0" lang="ja-JP">
                 <a:solidFill>
                   <a:srgbClr val="000000"/>
                 </a:solidFill>
@@ -5717,7 +5717,7 @@
               <a:t>𝒉</a:t>
             </a:r>
             <a:r>
-              <a:rPr sz="3000" b="0" i="0">
+              <a:rPr sz="3000" b="0" i="0" lang="ja-JP">
                 <a:solidFill>
                   <a:srgbClr val="000000"/>
                 </a:solidFill>
@@ -5740,7 +5740,7 @@
               <a:buChar char="•"/>
             </a:pPr>
             <a:r>
-              <a:rPr sz="3000" b="0" i="0">
+              <a:rPr sz="3000" b="0" i="0" lang="ja-JP">
                 <a:solidFill>
                   <a:srgbClr val="000000"/>
                 </a:solidFill>
@@ -5825,7 +5825,7 @@
               <a:buNone/>
             </a:pPr>
             <a:r>
-              <a:rPr sz="4000" b="1" i="0">
+              <a:rPr sz="4000" b="1" i="0" lang="ja-JP">
                 <a:solidFill>
                   <a:srgbClr val="FFFFFF"/>
                 </a:solidFill>
@@ -5868,7 +5868,7 @@
               <a:buNone/>
             </a:pPr>
             <a:r>
-              <a:rPr sz="3000" b="1" i="0">
+              <a:rPr sz="3000" b="1" i="0" lang="ja-JP">
                 <a:solidFill>
                   <a:srgbClr val="000000"/>
                 </a:solidFill>
@@ -5879,7 +5879,7 @@
               <a:t>モデル　</a:t>
             </a:r>
             <a:r>
-              <a:rPr sz="3000" b="0" i="0">
+              <a:rPr sz="3000" b="0" i="0" lang="ja-JP">
                 <a:solidFill>
                   <a:srgbClr val="000000"/>
                 </a:solidFill>
@@ -5901,7 +5901,7 @@
               <a:buNone/>
             </a:pPr>
             <a:r>
-              <a:rPr sz="3000" b="1" i="0">
+              <a:rPr sz="3000" b="1" i="0" lang="ja-JP">
                 <a:solidFill>
                   <a:srgbClr val="000000"/>
                 </a:solidFill>
@@ -5912,7 +5912,7 @@
               <a:t>学習　</a:t>
             </a:r>
             <a:r>
-              <a:rPr sz="3000" b="0" i="0">
+              <a:rPr sz="3000" b="0" i="0" lang="ja-JP">
                 <a:solidFill>
                   <a:srgbClr val="000000"/>
                 </a:solidFill>
@@ -5934,7 +5934,7 @@
               <a:buNone/>
             </a:pPr>
             <a:r>
-              <a:rPr sz="3000" b="1" i="0">
+              <a:rPr sz="3000" b="1" i="0" lang="ja-JP">
                 <a:solidFill>
                   <a:srgbClr val="000000"/>
                 </a:solidFill>
@@ -5945,7 +5945,7 @@
               <a:t>評価　</a:t>
             </a:r>
             <a:r>
-              <a:rPr sz="3000" b="0" i="0">
+              <a:rPr sz="3000" b="0" i="0" lang="ja-JP">
                 <a:solidFill>
                   <a:srgbClr val="000000"/>
                 </a:solidFill>
@@ -5997,7 +5997,7 @@
                         <a:buNone/>
                       </a:pPr>
                       <a:r>
-                        <a:rPr sz="2700" b="1" i="0">
+                        <a:rPr sz="2700" b="1" i="0" lang="ja-JP">
                           <a:solidFill>
                             <a:srgbClr val="FFFFFF"/>
                           </a:solidFill>
@@ -6030,7 +6030,7 @@
                         <a:buNone/>
                       </a:pPr>
                       <a:r>
-                        <a:rPr sz="2700" b="1" i="0">
+                        <a:rPr sz="2700" b="1" i="0" lang="ja-JP">
                           <a:solidFill>
                             <a:srgbClr val="FFFFFF"/>
                           </a:solidFill>
@@ -6063,7 +6063,7 @@
                         <a:buNone/>
                       </a:pPr>
                       <a:r>
-                        <a:rPr sz="2700" b="1" i="0">
+                        <a:rPr sz="2700" b="1" i="0" lang="ja-JP">
                           <a:solidFill>
                             <a:srgbClr val="FFFFFF"/>
                           </a:solidFill>
@@ -6098,7 +6098,7 @@
                         <a:buNone/>
                       </a:pPr>
                       <a:r>
-                        <a:rPr sz="2700" b="0" i="0">
+                        <a:rPr sz="2700" b="0" i="0" lang="ja-JP">
                           <a:solidFill>
                             <a:srgbClr val="000000"/>
                           </a:solidFill>
@@ -6131,7 +6131,7 @@
                         <a:buNone/>
                       </a:pPr>
                       <a:r>
-                        <a:rPr sz="2700" b="0" i="0">
+                        <a:rPr sz="2700" b="0" i="0" lang="ja-JP">
                           <a:solidFill>
                             <a:srgbClr val="000000"/>
                           </a:solidFill>
@@ -6164,7 +6164,7 @@
                         <a:buNone/>
                       </a:pPr>
                       <a:r>
-                        <a:rPr sz="2700" b="0" i="0">
+                        <a:rPr sz="2700" b="0" i="0" lang="ja-JP">
                           <a:solidFill>
                             <a:srgbClr val="000000"/>
                           </a:solidFill>
@@ -6199,7 +6199,7 @@
                         <a:buNone/>
                       </a:pPr>
                       <a:r>
-                        <a:rPr sz="2700" b="1" i="0">
+                        <a:rPr sz="2700" b="1" i="0" lang="ja-JP">
                           <a:solidFill>
                             <a:srgbClr val="000000"/>
                           </a:solidFill>
@@ -6232,7 +6232,7 @@
                         <a:buNone/>
                       </a:pPr>
                       <a:r>
-                        <a:rPr sz="2700" b="1" i="0">
+                        <a:rPr sz="2700" b="1" i="0" lang="ja-JP">
                           <a:solidFill>
                             <a:srgbClr val="000000"/>
                           </a:solidFill>
@@ -6265,7 +6265,7 @@
                         <a:buNone/>
                       </a:pPr>
                       <a:r>
-                        <a:rPr sz="2700" b="1" i="0">
+                        <a:rPr sz="2700" b="1" i="0" lang="ja-JP">
                           <a:solidFill>
                             <a:srgbClr val="000000"/>
                           </a:solidFill>
@@ -6300,7 +6300,7 @@
                         <a:buNone/>
                       </a:pPr>
                       <a:r>
-                        <a:rPr sz="2700" b="0" i="0">
+                        <a:rPr sz="2700" b="0" i="0" lang="ja-JP">
                           <a:solidFill>
                             <a:srgbClr val="000000"/>
                           </a:solidFill>
@@ -6333,7 +6333,7 @@
                         <a:buNone/>
                       </a:pPr>
                       <a:r>
-                        <a:rPr sz="2700" b="0" i="0">
+                        <a:rPr sz="2700" b="0" i="0" lang="ja-JP">
                           <a:solidFill>
                             <a:srgbClr val="000000"/>
                           </a:solidFill>
@@ -6366,7 +6366,7 @@
                         <a:buNone/>
                       </a:pPr>
                       <a:r>
-                        <a:rPr sz="2700" b="0" i="0">
+                        <a:rPr sz="2700" b="0" i="0" lang="ja-JP">
                           <a:solidFill>
                             <a:srgbClr val="000000"/>
                           </a:solidFill>
@@ -6419,7 +6419,7 @@
               <a:buNone/>
             </a:pPr>
             <a:r>
-              <a:rPr sz="2700" b="0" i="0">
+              <a:rPr sz="2700" b="0" i="0" lang="ja-JP">
                 <a:solidFill>
                   <a:srgbClr val="404040"/>
                 </a:solidFill>
@@ -6504,7 +6504,7 @@
               <a:buNone/>
             </a:pPr>
             <a:r>
-              <a:rPr sz="4000" b="1" i="0">
+              <a:rPr sz="4000" b="1" i="0" lang="ja-JP">
                 <a:solidFill>
                   <a:srgbClr val="FFFFFF"/>
                 </a:solidFill>
@@ -6547,7 +6547,7 @@
               <a:buNone/>
             </a:pPr>
             <a:r>
-              <a:rPr sz="3400" b="1" i="0">
+              <a:rPr sz="3400" b="1" i="0" lang="ja-JP">
                 <a:solidFill>
                   <a:srgbClr val="70AD47"/>
                 </a:solidFill>
@@ -6590,7 +6590,7 @@
               <a:buNone/>
             </a:pPr>
             <a:r>
-              <a:rPr sz="2700" b="0" i="0">
+              <a:rPr sz="2700" b="0" i="0" lang="ja-JP">
                 <a:solidFill>
                   <a:srgbClr val="000000"/>
                 </a:solidFill>
@@ -6601,7 +6601,7 @@
               <a:t>𝒉</a:t>
             </a:r>
             <a:r>
-              <a:rPr sz="2700" b="0" i="0">
+              <a:rPr sz="2700" b="0" i="0" lang="ja-JP">
                 <a:solidFill>
                   <a:srgbClr val="000000"/>
                 </a:solidFill>
@@ -6662,7 +6662,7 @@
               <a:buNone/>
             </a:pPr>
             <a:r>
-              <a:rPr sz="4400" b="1" i="0">
+              <a:rPr sz="4400" b="1" i="0" lang="ja-JP">
                 <a:solidFill>
                   <a:srgbClr val="C00000"/>
                 </a:solidFill>
@@ -6684,7 +6684,7 @@
               <a:buNone/>
             </a:pPr>
             <a:r>
-              <a:rPr sz="2700" b="0" i="0">
+              <a:rPr sz="2700" b="0" i="0" lang="ja-JP">
                 <a:solidFill>
                   <a:srgbClr val="000000"/>
                 </a:solidFill>
@@ -6727,7 +6727,7 @@
               <a:buNone/>
             </a:pPr>
             <a:r>
-              <a:rPr sz="3400" b="1" i="0">
+              <a:rPr sz="3400" b="1" i="0" lang="ja-JP">
                 <a:solidFill>
                   <a:srgbClr val="70AD47"/>
                 </a:solidFill>
@@ -6780,7 +6780,7 @@
                         <a:buNone/>
                       </a:pPr>
                       <a:r>
-                        <a:rPr sz="2700" b="1" i="0">
+                        <a:rPr sz="2700" b="1" i="0" lang="ja-JP">
                           <a:solidFill>
                             <a:srgbClr val="FFFFFF"/>
                           </a:solidFill>
@@ -6813,7 +6813,7 @@
                         <a:buNone/>
                       </a:pPr>
                       <a:r>
-                        <a:rPr sz="2700" b="1" i="0">
+                        <a:rPr sz="2700" b="1" i="0" lang="ja-JP">
                           <a:solidFill>
                             <a:srgbClr val="FFFFFF"/>
                           </a:solidFill>
@@ -6846,7 +6846,7 @@
                         <a:buNone/>
                       </a:pPr>
                       <a:r>
-                        <a:rPr sz="2700" b="1" i="0">
+                        <a:rPr sz="2700" b="1" i="0" lang="ja-JP">
                           <a:solidFill>
                             <a:srgbClr val="FFFFFF"/>
                           </a:solidFill>
@@ -6879,7 +6879,7 @@
                         <a:buNone/>
                       </a:pPr>
                       <a:r>
-                        <a:rPr sz="2700" b="1" i="0">
+                        <a:rPr sz="2700" b="1" i="0" lang="ja-JP">
                           <a:solidFill>
                             <a:srgbClr val="FFFFFF"/>
                           </a:solidFill>
@@ -6914,7 +6914,7 @@
                         <a:buNone/>
                       </a:pPr>
                       <a:r>
-                        <a:rPr sz="2700" b="0" i="0">
+                        <a:rPr sz="2700" b="0" i="0" lang="ja-JP">
                           <a:solidFill>
                             <a:srgbClr val="000000"/>
                           </a:solidFill>
@@ -6947,7 +6947,7 @@
                         <a:buNone/>
                       </a:pPr>
                       <a:r>
-                        <a:rPr sz="2700" b="0" i="0">
+                        <a:rPr sz="2700" b="0" i="0" lang="ja-JP">
                           <a:solidFill>
                             <a:srgbClr val="000000"/>
                           </a:solidFill>
@@ -6980,7 +6980,7 @@
                         <a:buNone/>
                       </a:pPr>
                       <a:r>
-                        <a:rPr sz="2700" b="0" i="0">
+                        <a:rPr sz="2700" b="0" i="0" lang="ja-JP">
                           <a:solidFill>
                             <a:srgbClr val="000000"/>
                           </a:solidFill>
@@ -7013,7 +7013,7 @@
                         <a:buNone/>
                       </a:pPr>
                       <a:r>
-                        <a:rPr sz="2700" b="0" i="0">
+                        <a:rPr sz="2700" b="0" i="0" lang="ja-JP">
                           <a:solidFill>
                             <a:srgbClr val="000000"/>
                           </a:solidFill>
@@ -7067,7 +7067,7 @@
               <a:buChar char="•"/>
             </a:pPr>
             <a:r>
-              <a:rPr sz="2700" b="0" i="0">
+              <a:rPr sz="2700" b="0" i="0" lang="ja-JP">
                 <a:solidFill>
                   <a:srgbClr val="000000"/>
                 </a:solidFill>
@@ -7090,7 +7090,7 @@
               <a:buChar char="•"/>
             </a:pPr>
             <a:r>
-              <a:rPr sz="2700" b="0" i="0">
+              <a:rPr sz="2700" b="0" i="0" lang="ja-JP">
                 <a:solidFill>
                   <a:srgbClr val="000000"/>
                 </a:solidFill>
@@ -7133,7 +7133,7 @@
               <a:buNone/>
             </a:pPr>
             <a:r>
-              <a:rPr sz="3400" b="1" i="0">
+              <a:rPr sz="3400" b="1" i="0" lang="ja-JP">
                 <a:solidFill>
                   <a:srgbClr val="70AD47"/>
                 </a:solidFill>
@@ -7176,7 +7176,7 @@
               <a:buNone/>
             </a:pPr>
             <a:r>
-              <a:rPr sz="3000" b="1" i="0">
+              <a:rPr sz="3000" b="1" i="0" lang="ja-JP">
                 <a:solidFill>
                   <a:srgbClr val="000000"/>
                 </a:solidFill>
@@ -7187,7 +7187,7 @@
               <a:t>相対感度　</a:t>
             </a:r>
             <a:r>
-              <a:rPr sz="3000" b="0" i="0">
+              <a:rPr sz="3000" b="0" i="0" lang="ja-JP">
                 <a:solidFill>
                   <a:srgbClr val="000000"/>
                 </a:solidFill>
@@ -7198,7 +7198,7 @@
               <a:t>𝑒 = ‖𝑱</a:t>
             </a:r>
             <a:r>
-              <a:rPr sz="2000" b="0" i="0">
+              <a:rPr sz="2000" b="0" i="0" lang="ja-JP">
                 <a:solidFill>
                   <a:srgbClr val="000000"/>
                 </a:solidFill>
@@ -7209,7 +7209,7 @@
               <a:t>⊤</a:t>
             </a:r>
             <a:r>
-              <a:rPr sz="3000" b="0" i="0">
+              <a:rPr sz="3000" b="0" i="0" lang="ja-JP">
                 <a:solidFill>
                   <a:srgbClr val="000000"/>
                 </a:solidFill>
@@ -7231,7 +7231,7 @@
               <a:buNone/>
             </a:pPr>
             <a:r>
-              <a:rPr sz="2700" b="0" i="0">
+              <a:rPr sz="2700" b="0" i="0" lang="ja-JP">
                 <a:solidFill>
                   <a:srgbClr val="404040"/>
                 </a:solidFill>
@@ -7242,7 +7242,7 @@
               <a:t>𝒉</a:t>
             </a:r>
             <a:r>
-              <a:rPr sz="2700" b="0" i="0">
+              <a:rPr sz="2700" b="0" i="0" lang="ja-JP">
                 <a:solidFill>
                   <a:srgbClr val="404040"/>
                 </a:solidFill>
@@ -7253,7 +7253,7 @@
               <a:t>を1%動かしたとき，正規化した出力</a:t>
             </a:r>
             <a:r>
-              <a:rPr sz="2700" b="0" i="0">
+              <a:rPr sz="2700" b="0" i="0" lang="ja-JP">
                 <a:solidFill>
                   <a:srgbClr val="404040"/>
                 </a:solidFill>
@@ -7264,7 +7264,7 @@
               <a:t>𝒓</a:t>
             </a:r>
             <a:r>
-              <a:rPr sz="2700" b="0" i="0">
+              <a:rPr sz="2700" b="0" i="0" lang="ja-JP">
                 <a:solidFill>
                   <a:srgbClr val="404040"/>
                 </a:solidFill>
@@ -7275,7 +7275,7 @@
               <a:t>が回答を決める方向</a:t>
             </a:r>
             <a:r>
-              <a:rPr sz="2700" b="0" i="0">
+              <a:rPr sz="2700" b="0" i="0" lang="ja-JP">
                 <a:solidFill>
                   <a:srgbClr val="404040"/>
                 </a:solidFill>
@@ -7286,7 +7286,7 @@
               <a:t>𝒖</a:t>
             </a:r>
             <a:r>
-              <a:rPr sz="2700" b="0" i="0">
+              <a:rPr sz="2700" b="0" i="0" lang="ja-JP">
                 <a:solidFill>
                   <a:srgbClr val="404040"/>
                 </a:solidFill>
@@ -7297,7 +7297,7 @@
               <a:t>へ最大で何%動くか．</a:t>
             </a:r>
             <a:r>
-              <a:rPr sz="2700" b="0" i="0">
+              <a:rPr sz="2700" b="0" i="0" lang="ja-JP">
                 <a:solidFill>
                   <a:srgbClr val="404040"/>
                 </a:solidFill>
@@ -7308,7 +7308,7 @@
               <a:t>𝒖</a:t>
             </a:r>
             <a:r>
-              <a:rPr sz="2700" b="0" i="0">
+              <a:rPr sz="2700" b="0" i="0" lang="ja-JP">
                 <a:solidFill>
                   <a:srgbClr val="404040"/>
                 </a:solidFill>
@@ -7319,7 +7319,7 @@
               <a:t>は回答の候補の出力層の行の主成分（上位</a:t>
             </a:r>
             <a:r>
-              <a:rPr sz="2700" b="0" i="0">
+              <a:rPr sz="2700" b="0" i="0" lang="ja-JP">
                 <a:solidFill>
                   <a:srgbClr val="404040"/>
                 </a:solidFill>
@@ -7330,7 +7330,7 @@
               <a:t>𝑚</a:t>
             </a:r>
             <a:r>
-              <a:rPr sz="2700" b="0" i="0">
+              <a:rPr sz="2700" b="0" i="0" lang="ja-JP">
                 <a:solidFill>
                   <a:srgbClr val="404040"/>
                 </a:solidFill>
@@ -7341,7 +7341,7 @@
               <a:t>本），</a:t>
             </a:r>
             <a:r>
-              <a:rPr sz="2700" b="0" i="0">
+              <a:rPr sz="2700" b="0" i="0" lang="ja-JP">
                 <a:solidFill>
                   <a:srgbClr val="404040"/>
                 </a:solidFill>
@@ -7352,7 +7352,7 @@
               <a:t>𝑱</a:t>
             </a:r>
             <a:r>
-              <a:rPr sz="2700" b="0" i="0">
+              <a:rPr sz="2700" b="0" i="0" lang="ja-JP">
                 <a:solidFill>
                   <a:srgbClr val="404040"/>
                 </a:solidFill>
@@ -7413,7 +7413,7 @@
               <a:buNone/>
             </a:pPr>
             <a:r>
-              <a:rPr sz="2700" b="1" i="0">
+              <a:rPr sz="2700" b="1" i="0" lang="ja-JP">
                 <a:solidFill>
                   <a:srgbClr val="C00000"/>
                 </a:solidFill>
@@ -7424,7 +7424,7 @@
               <a:t>proposal は baseline より18–28%低い</a:t>
             </a:r>
             <a:r>
-              <a:rPr sz="2700" b="0" i="0">
+              <a:rPr sz="2700" b="0" i="0" lang="ja-JP">
                 <a:solidFill>
                   <a:srgbClr val="000000"/>
                 </a:solidFill>
@@ -7509,7 +7509,7 @@
               <a:buNone/>
             </a:pPr>
             <a:r>
-              <a:rPr sz="4000" b="1" i="0">
+              <a:rPr sz="4000" b="1" i="0" lang="ja-JP">
                 <a:solidFill>
                   <a:srgbClr val="FFFFFF"/>
                 </a:solidFill>
@@ -7552,7 +7552,7 @@
               <a:buNone/>
             </a:pPr>
             <a:r>
-              <a:rPr sz="2700" b="0" i="0">
+              <a:rPr sz="2700" b="0" i="0" lang="ja-JP">
                 <a:solidFill>
                   <a:srgbClr val="000000"/>
                 </a:solidFill>
@@ -7563,7 +7563,7 @@
               <a:t>予稿以降に測定．Waniら[1]の加工8族23通りを評価データの全問に施し，第16層の</a:t>
             </a:r>
             <a:r>
-              <a:rPr sz="2700" b="0" i="0">
+              <a:rPr sz="2700" b="0" i="0" lang="ja-JP">
                 <a:solidFill>
                   <a:srgbClr val="000000"/>
                 </a:solidFill>
@@ -7574,7 +7574,7 @@
               <a:t>𝒉</a:t>
             </a:r>
             <a:r>
-              <a:rPr sz="2700" b="0" i="0">
+              <a:rPr sz="2700" b="0" i="0" lang="ja-JP">
                 <a:solidFill>
                   <a:srgbClr val="000000"/>
                 </a:solidFill>
@@ -7641,7 +7641,7 @@
               <a:buNone/>
             </a:pPr>
             <a:r>
-              <a:rPr sz="1800" b="0" i="0">
+              <a:rPr sz="1800" b="0" i="0" lang="ja-JP">
                 <a:solidFill>
                   <a:srgbClr val="000000"/>
                 </a:solidFill>
@@ -7708,7 +7708,7 @@
               <a:buNone/>
             </a:pPr>
             <a:r>
-              <a:rPr sz="1800" b="0" i="0">
+              <a:rPr sz="1800" b="0" i="0" lang="ja-JP">
                 <a:solidFill>
                   <a:srgbClr val="000000"/>
                 </a:solidFill>
@@ -7775,7 +7775,7 @@
               <a:buNone/>
             </a:pPr>
             <a:r>
-              <a:rPr sz="1800" b="0" i="0">
+              <a:rPr sz="1800" b="0" i="0" lang="ja-JP">
                 <a:solidFill>
                   <a:srgbClr val="000000"/>
                 </a:solidFill>
@@ -7842,7 +7842,7 @@
               <a:buNone/>
             </a:pPr>
             <a:r>
-              <a:rPr sz="1800" b="0" i="0">
+              <a:rPr sz="1800" b="0" i="0" lang="ja-JP">
                 <a:solidFill>
                   <a:srgbClr val="000000"/>
                 </a:solidFill>
@@ -7909,7 +7909,7 @@
               <a:buNone/>
             </a:pPr>
             <a:r>
-              <a:rPr sz="1800" b="0" i="0">
+              <a:rPr sz="1800" b="0" i="0" lang="ja-JP">
                 <a:solidFill>
                   <a:srgbClr val="000000"/>
                 </a:solidFill>
@@ -7952,7 +7952,7 @@
               <a:buNone/>
             </a:pPr>
             <a:r>
-              <a:rPr sz="1800" b="0" i="0">
+              <a:rPr sz="1800" b="0" i="0" lang="ja-JP">
                 <a:solidFill>
                   <a:srgbClr val="595959"/>
                 </a:solidFill>
@@ -7995,7 +7995,7 @@
               <a:buNone/>
             </a:pPr>
             <a:r>
-              <a:rPr sz="2700" b="1" i="0">
+              <a:rPr sz="2700" b="1" i="0" lang="ja-JP">
                 <a:solidFill>
                   <a:srgbClr val="000000"/>
                 </a:solidFill>
@@ -8006,7 +8006,7 @@
               <a:t>比</a:t>
             </a:r>
             <a:r>
-              <a:rPr sz="2700" b="0" i="0">
+              <a:rPr sz="2700" b="0" i="0" lang="ja-JP">
                 <a:solidFill>
                   <a:srgbClr val="000000"/>
                 </a:solidFill>
@@ -8067,7 +8067,7 @@
               <a:buNone/>
             </a:pPr>
             <a:r>
-              <a:rPr sz="2200" b="0" i="0">
+              <a:rPr sz="2200" b="0" i="0" lang="ja-JP">
                 <a:solidFill>
                   <a:srgbClr val="595959"/>
                 </a:solidFill>
@@ -8111,7 +8111,7 @@
               <a:buChar char="•"/>
             </a:pPr>
             <a:r>
-              <a:rPr sz="2700" b="1" i="0">
+              <a:rPr sz="2700" b="1" i="0" lang="ja-JP">
                 <a:solidFill>
                   <a:srgbClr val="000000"/>
                 </a:solidFill>
@@ -8122,7 +8122,7 @@
               <a:t>23通りすべて　</a:t>
             </a:r>
             <a:r>
-              <a:rPr sz="2700" b="0" i="0">
+              <a:rPr sz="2700" b="0" i="0" lang="ja-JP">
                 <a:solidFill>
                   <a:srgbClr val="000000"/>
                 </a:solidFill>
@@ -8145,7 +8145,7 @@
               <a:buChar char="•"/>
             </a:pPr>
             <a:r>
-              <a:rPr sz="2700" b="1" i="0">
+              <a:rPr sz="2700" b="1" i="0" lang="ja-JP">
                 <a:solidFill>
                   <a:srgbClr val="000000"/>
                 </a:solidFill>
@@ -8156,7 +8156,7 @@
               <a:t>ablation より小さい　</a:t>
             </a:r>
             <a:r>
-              <a:rPr sz="2700" b="0" i="0">
+              <a:rPr sz="2700" b="0" i="0" lang="ja-JP">
                 <a:solidFill>
                   <a:srgbClr val="000000"/>
                 </a:solidFill>
@@ -8179,7 +8179,7 @@
               <a:buChar char="•"/>
             </a:pPr>
             <a:r>
-              <a:rPr sz="2700" b="1" i="0">
+              <a:rPr sz="2700" b="1" i="0" lang="ja-JP">
                 <a:solidFill>
                   <a:srgbClr val="000000"/>
                 </a:solidFill>
@@ -8190,7 +8190,7 @@
               <a:t>baseline との差は向きが未決　</a:t>
             </a:r>
             <a:r>
-              <a:rPr sz="2700" b="0" i="0">
+              <a:rPr sz="2700" b="0" i="0" lang="ja-JP">
                 <a:solidFill>
                   <a:srgbClr val="000000"/>
                 </a:solidFill>
@@ -8213,7 +8213,7 @@
               <a:buChar char="•"/>
             </a:pPr>
             <a:r>
-              <a:rPr sz="2700" b="0" i="0">
+              <a:rPr sz="2700" b="0" i="0" lang="ja-JP">
                 <a:solidFill>
                   <a:srgbClr val="000000"/>
                 </a:solidFill>
@@ -8298,7 +8298,7 @@
               <a:buNone/>
             </a:pPr>
             <a:r>
-              <a:rPr sz="4000" b="1" i="0">
+              <a:rPr sz="4000" b="1" i="0" lang="ja-JP">
                 <a:solidFill>
                   <a:srgbClr val="FFFFFF"/>
                 </a:solidFill>
@@ -8387,7 +8387,7 @@
               <a:buNone/>
             </a:pPr>
             <a:r>
-              <a:rPr sz="3400" b="1" i="0">
+              <a:rPr sz="3400" b="1" i="0" lang="ja-JP">
                 <a:solidFill>
                   <a:srgbClr val="000000"/>
                 </a:solidFill>
@@ -8431,7 +8431,7 @@
               <a:buChar char="•"/>
             </a:pPr>
             <a:r>
-              <a:rPr sz="2700" b="0" i="0">
+              <a:rPr sz="2700" b="0" i="0" lang="ja-JP">
                 <a:solidFill>
                   <a:srgbClr val="000000"/>
                 </a:solidFill>
@@ -8454,7 +8454,7 @@
               <a:buChar char="•"/>
             </a:pPr>
             <a:r>
-              <a:rPr sz="2700" b="1" i="0">
+              <a:rPr sz="2700" b="1" i="0" lang="ja-JP">
                 <a:solidFill>
                   <a:srgbClr val="000000"/>
                 </a:solidFill>
@@ -8465,7 +8465,7 @@
               <a:t>今後　</a:t>
             </a:r>
             <a:r>
-              <a:rPr sz="2700" b="0" i="0">
+              <a:rPr sz="2700" b="0" i="0" lang="ja-JP">
                 <a:solidFill>
                   <a:srgbClr val="000000"/>
                 </a:solidFill>
@@ -8488,7 +8488,7 @@
               <a:buChar char="•"/>
             </a:pPr>
             <a:r>
-              <a:rPr sz="2700" b="1" i="0">
+              <a:rPr sz="2700" b="1" i="0" lang="ja-JP">
                 <a:solidFill>
                   <a:srgbClr val="000000"/>
                 </a:solidFill>
@@ -8499,7 +8499,7 @@
               <a:t>限界　</a:t>
             </a:r>
             <a:r>
-              <a:rPr sz="2700" b="0" i="0">
+              <a:rPr sz="2700" b="0" i="0" lang="ja-JP">
                 <a:solidFill>
                   <a:srgbClr val="000000"/>
                 </a:solidFill>
@@ -8510,7 +8510,7 @@
               <a:t>1モデル・1データセット・第16層・</a:t>
             </a:r>
             <a:r>
-              <a:rPr sz="2700" b="0" i="0">
+              <a:rPr sz="2700" b="0" i="0" lang="ja-JP">
                 <a:solidFill>
                   <a:srgbClr val="000000"/>
                 </a:solidFill>
@@ -8521,7 +8521,7 @@
               <a:t>𝜆 = 0.1</a:t>
             </a:r>
             <a:r>
-              <a:rPr sz="2700" b="0" i="0">
+              <a:rPr sz="2700" b="0" i="0" lang="ja-JP">
                 <a:solidFill>
                   <a:srgbClr val="000000"/>
                 </a:solidFill>
@@ -8610,7 +8610,7 @@
               <a:buNone/>
             </a:pPr>
             <a:r>
-              <a:rPr sz="2700" b="1" i="0">
+              <a:rPr sz="2700" b="1" i="0" lang="ja-JP">
                 <a:solidFill>
                   <a:srgbClr val="70AD47"/>
                 </a:solidFill>
@@ -8621,7 +8621,7 @@
               <a:t>研究の意義　</a:t>
             </a:r>
             <a:r>
-              <a:rPr sz="2700" b="0" i="0">
+              <a:rPr sz="2700" b="0" i="0" lang="ja-JP">
                 <a:solidFill>
                   <a:srgbClr val="000000"/>
                 </a:solidFill>
@@ -8643,7 +8643,7 @@
               <a:buNone/>
             </a:pPr>
             <a:r>
-              <a:rPr sz="2700" b="1" i="0">
+              <a:rPr sz="2700" b="1" i="0" lang="ja-JP">
                 <a:solidFill>
                   <a:srgbClr val="000000"/>
                 </a:solidFill>
@@ -8686,7 +8686,7 @@
               <a:buNone/>
             </a:pPr>
             <a:r>
-              <a:rPr sz="1500" b="0" i="0">
+              <a:rPr sz="1500" b="0" i="0" lang="ja-JP">
                 <a:solidFill>
                   <a:srgbClr val="404040"/>
                 </a:solidFill>
@@ -8708,7 +8708,7 @@
               <a:buNone/>
             </a:pPr>
             <a:r>
-              <a:rPr sz="1500" b="0" i="0">
+              <a:rPr sz="1500" b="0" i="0" lang="ja-JP">
                 <a:solidFill>
                   <a:srgbClr val="404040"/>
                 </a:solidFill>
@@ -8730,7 +8730,7 @@
               <a:buNone/>
             </a:pPr>
             <a:r>
-              <a:rPr sz="1500" b="0" i="0">
+              <a:rPr sz="1500" b="0" i="0" lang="ja-JP">
                 <a:solidFill>
                   <a:srgbClr val="404040"/>
                 </a:solidFill>
@@ -8752,7 +8752,7 @@
               <a:buNone/>
             </a:pPr>
             <a:r>
-              <a:rPr sz="1500" b="0" i="0">
+              <a:rPr sz="1500" b="0" i="0" lang="ja-JP">
                 <a:solidFill>
                   <a:srgbClr val="404040"/>
                 </a:solidFill>
@@ -8774,7 +8774,7 @@
               <a:buNone/>
             </a:pPr>
             <a:r>
-              <a:rPr sz="1500" b="0" i="0">
+              <a:rPr sz="1500" b="0" i="0" lang="ja-JP">
                 <a:solidFill>
                   <a:srgbClr val="404040"/>
                 </a:solidFill>
@@ -8838,10 +8838,10 @@
     </a:clrScheme>
     <a:fontScheme name="Office">
       <a:majorFont>
-        <a:latin typeface="Calibri"/>
-        <a:ea typeface=""/>
+        <a:latin typeface="游ゴシック"/>
+        <a:ea typeface="游ゴシック"/>
         <a:cs typeface=""/>
-        <a:font script="Jpan" typeface="ＭＳ Ｐゴシック"/>
+        <a:font script="Jpan" typeface="游ゴシック"/>
         <a:font script="Hang" typeface="맑은 고딕"/>
         <a:font script="Hans" typeface="宋体"/>
         <a:font script="Hant" typeface="新細明體"/>
@@ -8873,10 +8873,10 @@
         <a:font script="Geor" typeface="Sylfaen"/>
       </a:majorFont>
       <a:minorFont>
-        <a:latin typeface="Calibri"/>
-        <a:ea typeface=""/>
+        <a:latin typeface="游ゴシック"/>
+        <a:ea typeface="游ゴシック"/>
         <a:cs typeface=""/>
-        <a:font script="Jpan" typeface="ＭＳ Ｐゴシック"/>
+        <a:font script="Jpan" typeface="游ゴシック"/>
         <a:font script="Hang" typeface="맑은 고딕"/>
         <a:font script="Hans" typeface="宋体"/>
         <a:font script="Hant" typeface="新細明體"/>

</xml_diff>

<commit_message>
docs: tidy the decks' line breaks and formulas
Rendered page by page, several lines broke inside a phrase or left
one or two characters alone, the family chart wrapped its last
category, and the poster set LM, align and the transpose as small
text on the baseline. Lines now break where the sense does, a few
phrases are shortened to fit without changing their claim, and the
chart's last category reads "23通り" as on the poster. Sub- and
superscripts carry PowerPoint's baseline shift, and the table's
lambda is in the math face like the rest. The poster's first column
spreads its spare height over its gaps, ending level with the
second, and the deck's preview of the poster is redrawn.
</commit_message>
<xml_diff>
--- a/presentations/20261116_PCSJ-IMPS2026_ポスター初案.pptx
+++ b/presentations/20261116_PCSJ-IMPS2026_ポスター初案.pptx
@@ -4947,7 +4947,7 @@
         </p:nvSpPr>
         <p:spPr>
           <a:xfrm>
-            <a:off x="792000" y="11337553"/>
+            <a:off x="792000" y="11625553"/>
             <a:ext cx="13308000" cy="2105457"/>
           </a:xfrm>
           <a:prstGeom prst="roundRect">
@@ -4993,7 +4993,7 @@
         </p:nvSpPr>
         <p:spPr>
           <a:xfrm>
-            <a:off x="1008000" y="11553553"/>
+            <a:off x="1008000" y="11841553"/>
             <a:ext cx="12876000" cy="1673457"/>
           </a:xfrm>
           <a:prstGeom prst="rect">
@@ -5047,7 +5047,7 @@
         </p:nvSpPr>
         <p:spPr>
           <a:xfrm>
-            <a:off x="792000" y="13695011"/>
+            <a:off x="792000" y="14271011"/>
             <a:ext cx="13308000" cy="684000"/>
           </a:xfrm>
           <a:prstGeom prst="rect">
@@ -5089,7 +5089,7 @@
         </p:nvSpPr>
         <p:spPr>
           <a:xfrm>
-            <a:off x="1008000" y="13695011"/>
+            <a:off x="1008000" y="14271011"/>
             <a:ext cx="12876000" cy="684000"/>
           </a:xfrm>
           <a:prstGeom prst="rect">
@@ -5140,7 +5140,7 @@
         </p:blipFill>
         <p:spPr>
           <a:xfrm>
-            <a:off x="792000" y="14595011"/>
+            <a:off x="792000" y="15315011"/>
             <a:ext cx="13308000" cy="3784753"/>
           </a:xfrm>
           <a:prstGeom prst="rect">
@@ -5156,7 +5156,7 @@
         </p:nvSpPr>
         <p:spPr>
           <a:xfrm>
-            <a:off x="792000" y="18451764"/>
+            <a:off x="792000" y="19171764"/>
             <a:ext cx="13308000" cy="453673"/>
           </a:xfrm>
           <a:prstGeom prst="rect">
@@ -5199,7 +5199,7 @@
         </p:nvSpPr>
         <p:spPr>
           <a:xfrm>
-            <a:off x="792000" y="19085436"/>
+            <a:off x="792000" y="20093436"/>
             <a:ext cx="13308000" cy="1724261"/>
           </a:xfrm>
           <a:prstGeom prst="rect">
@@ -5254,8 +5254,8 @@
           <p:nvPr/>
         </p:nvGraphicFramePr>
         <p:xfrm>
-          <a:off x="792000" y="21025697"/>
-          <a:ext cx="13308000" cy="2880000"/>
+          <a:off x="792000" y="22321697"/>
+          <a:ext cx="13308000" cy="3312000"/>
         </p:xfrm>
         <a:graphic>
           <a:graphicData uri="http://schemas.openxmlformats.org/drawingml/2006/table">
@@ -5267,7 +5267,7 @@
                 <a:gridCol w="7053240"/>
                 <a:gridCol w="6254760"/>
               </a:tblGrid>
-              <a:tr h="720000">
+              <a:tr h="828000">
                 <a:tc>
                   <a:txBody>
                     <a:bodyPr wrap="square"/>
@@ -5335,7 +5335,7 @@
                   </a:tcPr>
                 </a:tc>
               </a:tr>
-              <a:tr h="720000">
+              <a:tr h="828000">
                 <a:tc>
                   <a:txBody>
                     <a:bodyPr wrap="square"/>
@@ -5403,7 +5403,7 @@
                   </a:tcPr>
                 </a:tc>
               </a:tr>
-              <a:tr h="720000">
+              <a:tr h="828000">
                 <a:tc>
                   <a:txBody>
                     <a:bodyPr wrap="square"/>
@@ -5471,7 +5471,7 @@
                   </a:tcPr>
                 </a:tc>
               </a:tr>
-              <a:tr h="720000">
+              <a:tr h="828000">
                 <a:tc>
                   <a:txBody>
                     <a:bodyPr wrap="square"/>
@@ -5551,7 +5551,7 @@
         </p:nvSpPr>
         <p:spPr>
           <a:xfrm>
-            <a:off x="792000" y="24229697"/>
+            <a:off x="792000" y="26245697"/>
             <a:ext cx="13308000" cy="2645831"/>
           </a:xfrm>
           <a:prstGeom prst="rect">
@@ -5595,7 +5595,7 @@
               <a:t>ℒ = ℒ</a:t>
             </a:r>
             <a:r>
-              <a:rPr sz="2000" b="0" i="0" lang="ja-JP">
+              <a:rPr sz="3600" b="0" i="0" lang="ja-JP" baseline="-25000">
                 <a:solidFill>
                   <a:srgbClr val="000000"/>
                 </a:solidFill>
@@ -5617,7 +5617,7 @@
               <a:t> + 𝜆ℒ</a:t>
             </a:r>
             <a:r>
-              <a:rPr sz="2000" b="0" i="0" lang="ja-JP">
+              <a:rPr sz="3600" b="0" i="0" lang="ja-JP" baseline="-25000">
                 <a:solidFill>
                   <a:srgbClr val="000000"/>
                 </a:solidFill>
@@ -5684,7 +5684,7 @@
               <a:t>ℒ</a:t>
             </a:r>
             <a:r>
-              <a:rPr sz="2000" b="0" i="0" lang="ja-JP">
+              <a:rPr sz="3000" b="0" i="0" lang="ja-JP" baseline="-25000">
                 <a:solidFill>
                   <a:srgbClr val="000000"/>
                 </a:solidFill>
@@ -6034,9 +6034,9 @@
                           <a:solidFill>
                             <a:srgbClr val="FFFFFF"/>
                           </a:solidFill>
-                          <a:latin typeface="游ゴシック"/>
-                          <a:ea typeface="游ゴシック"/>
-                          <a:cs typeface="游ゴシック"/>
+                          <a:latin typeface="Cambria Math"/>
+                          <a:ea typeface="Cambria Math"/>
+                          <a:cs typeface="Cambria Math"/>
                         </a:rPr>
                         <a:t>𝜆</a:t>
                       </a:r>
@@ -6692,7 +6692,7 @@
                 <a:ea typeface="游ゴシック"/>
                 <a:cs typeface="游ゴシック"/>
               </a:rPr>
-              <a:t>署名を並べ替えると消え，質問文の語だけでは説明できない</a:t>
+              <a:t>署名を並べ替えると消え，質問文の語では説明できない</a:t>
             </a:r>
           </a:p>
         </p:txBody>
@@ -7198,7 +7198,7 @@
               <a:t>𝑒 = ‖𝑱</a:t>
             </a:r>
             <a:r>
-              <a:rPr sz="2000" b="0" i="0" lang="ja-JP">
+              <a:rPr sz="3000" b="0" i="0" lang="ja-JP" baseline="30000">
                 <a:solidFill>
                   <a:srgbClr val="000000"/>
                 </a:solidFill>
@@ -7582,7 +7582,7 @@
                 <a:ea typeface="游ゴシック"/>
                 <a:cs typeface="游ゴシック"/>
               </a:rPr>
-              <a:t>の動きを3群で比べた</a:t>
+              <a:t>の動き（コサイン距離）を3群で比べた</a:t>
             </a:r>
           </a:p>
         </p:txBody>
@@ -8014,7 +8014,7 @@
                 <a:ea typeface="游ゴシック"/>
                 <a:cs typeface="游ゴシック"/>
               </a:rPr>
-              <a:t>　加工の前後の距離 ÷ 同じ質問に別の画像を与えたときの距離（コサイン距離の平均）</a:t>
+              <a:t>　加工前後の距離の平均 ÷ 同じ質問に別の画像を与えたときの距離の平均</a:t>
             </a:r>
           </a:p>
         </p:txBody>
@@ -8395,7 +8395,28 @@
                 <a:ea typeface="游ゴシック"/>
                 <a:cs typeface="游ゴシック"/>
               </a:rPr>
-              <a:t>内部表現に表れた手続きの特徴は，回答の生成に十分用いられていないことが示唆される</a:t>
+              <a:t>内部表現に表れた手続きの特徴は，</a:t>
+            </a:r>
+            <a:br>
+              <a:rPr sz="3400" b="1" i="0" lang="ja-JP">
+                <a:solidFill>
+                  <a:srgbClr val="000000"/>
+                </a:solidFill>
+                <a:latin typeface="游ゴシック"/>
+                <a:ea typeface="游ゴシック"/>
+                <a:cs typeface="游ゴシック"/>
+              </a:rPr>
+            </a:br>
+            <a:r>
+              <a:rPr sz="3400" b="1" i="0" lang="ja-JP">
+                <a:solidFill>
+                  <a:srgbClr val="000000"/>
+                </a:solidFill>
+                <a:latin typeface="游ゴシック"/>
+                <a:ea typeface="游ゴシック"/>
+                <a:cs typeface="游ゴシック"/>
+              </a:rPr>
+              <a:t>回答の生成に十分用いられていないことが示唆される</a:t>
             </a:r>
           </a:p>
         </p:txBody>
@@ -8529,7 +8550,7 @@
                 <a:ea typeface="游ゴシック"/>
                 <a:cs typeface="游ゴシック"/>
               </a:rPr>
-              <a:t>での結果．相対感度は一次近似</a:t>
+              <a:t>．相対感度は一次近似</a:t>
             </a:r>
           </a:p>
         </p:txBody>

</xml_diff>

<commit_message>
docs: say in the decks that raw distance disagrees
The decks gave only the ratio, which the raw distance at layer 16
contradicts, and one slide called the perturbations Wani et al.'s
own, though the directive departs. The deck's denominator slide now
says every ratio yardstick orders the arms proposal < baseline <
ablation and the raw distance the reverse; the summary adds that the
raw distance is larger for the proposal with an interval excluding
zero; the plan says the five-seed decision will weigh it; the notes
give the numbers and what the ratio does not mean. The question slide
says the perturbations and measures follow Wani et al. The poster's
section 5 gains the same line, its section 6 moves down to make room,
and the deck's preview of the poster is redrawn.
</commit_message>
<xml_diff>
--- a/presentations/20261116_PCSJ-IMPS2026_ポスター初案.pptx
+++ b/presentations/20261116_PCSJ-IMPS2026_ポスター初案.pptx
@@ -8089,7 +8089,7 @@
         <p:spPr>
           <a:xfrm>
             <a:off x="28704000" y="16019869"/>
-            <a:ext cx="13308000" cy="2244231"/>
+            <a:ext cx="13308000" cy="3108231"/>
           </a:xfrm>
           <a:prstGeom prst="rect">
             <a:avLst/>
@@ -8213,6 +8213,40 @@
               <a:buChar char="•"/>
             </a:pPr>
             <a:r>
+              <a:rPr sz="2700" b="1" i="0" lang="ja-JP">
+                <a:solidFill>
+                  <a:srgbClr val="000000"/>
+                </a:solidFill>
+                <a:latin typeface="游ゴシック"/>
+                <a:ea typeface="游ゴシック"/>
+                <a:cs typeface="游ゴシック"/>
+              </a:rPr>
+              <a:t>距離そのものでは逆向き　</a:t>
+            </a:r>
+            <a:r>
+              <a:rPr sz="2700" b="0" i="0" lang="ja-JP">
+                <a:solidFill>
+                  <a:srgbClr val="000000"/>
+                </a:solidFill>
+                <a:latin typeface="游ゴシック"/>
+                <a:ea typeface="游ゴシック"/>
+                <a:cs typeface="游ゴシック"/>
+              </a:rPr>
+              <a:t>proposal のほうがよく動き（区間は0を含まない），対照の距離も約5倍</a:t>
+            </a:r>
+          </a:p>
+          <a:p>
+            <a:pPr marL="342900" indent="-342900">
+              <a:lnSpc>
+                <a:spcPts val="3294"/>
+              </a:lnSpc>
+              <a:spcAft>
+                <a:spcPts val="300"/>
+              </a:spcAft>
+              <a:buFont typeface="Arial"/>
+              <a:buChar char="•"/>
+            </a:pPr>
+            <a:r>
               <a:rPr sz="2700" b="0" i="0" lang="ja-JP">
                 <a:solidFill>
                   <a:srgbClr val="000000"/>
@@ -8234,7 +8268,7 @@
         </p:nvSpPr>
         <p:spPr>
           <a:xfrm>
-            <a:off x="28704000" y="18480101"/>
+            <a:off x="28704000" y="19344101"/>
             <a:ext cx="13308000" cy="684000"/>
           </a:xfrm>
           <a:prstGeom prst="rect">
@@ -8276,7 +8310,7 @@
         </p:nvSpPr>
         <p:spPr>
           <a:xfrm>
-            <a:off x="28920000" y="18480101"/>
+            <a:off x="28920000" y="19344101"/>
             <a:ext cx="12876000" cy="684000"/>
           </a:xfrm>
           <a:prstGeom prst="rect">
@@ -8319,7 +8353,7 @@
         </p:nvSpPr>
         <p:spPr>
           <a:xfrm>
-            <a:off x="28704000" y="19380101"/>
+            <a:off x="28704000" y="20244101"/>
             <a:ext cx="13308000" cy="1485658"/>
           </a:xfrm>
           <a:prstGeom prst="roundRect">
@@ -8365,7 +8399,7 @@
         </p:nvSpPr>
         <p:spPr>
           <a:xfrm>
-            <a:off x="28920000" y="19596101"/>
+            <a:off x="28920000" y="20460101"/>
             <a:ext cx="12876000" cy="1053658"/>
           </a:xfrm>
           <a:prstGeom prst="rect">
@@ -8429,7 +8463,7 @@
         </p:nvSpPr>
         <p:spPr>
           <a:xfrm>
-            <a:off x="28704000" y="21117759"/>
+            <a:off x="28704000" y="21981759"/>
             <a:ext cx="13308000" cy="2206129"/>
           </a:xfrm>
           <a:prstGeom prst="rect">
@@ -8563,7 +8597,7 @@
         </p:nvSpPr>
         <p:spPr>
           <a:xfrm>
-            <a:off x="28704000" y="23539888"/>
+            <a:off x="28704000" y="24403888"/>
             <a:ext cx="13308000" cy="2574625"/>
           </a:xfrm>
           <a:prstGeom prst="roundRect">
@@ -8609,7 +8643,7 @@
         </p:nvSpPr>
         <p:spPr>
           <a:xfrm>
-            <a:off x="28920000" y="23755888"/>
+            <a:off x="28920000" y="24619888"/>
             <a:ext cx="12876000" cy="2142625"/>
           </a:xfrm>
           <a:prstGeom prst="rect">

</xml_diff>

<commit_message>
docs: hold both decks to the rules they missed
A scan of both decks against the presentation rules found what
the last pass let through.

- No full-width brackets or plus: the talk's labels take angle
  brackets and the poster's chart reads "縮小と余白".
- One name and one strength per thing: the talk's notes say
  "整合した群" and that accuracy hardly moves, and its table and
  red line spell out proposal − baseline.
- One precision per quantity: the poster quotes the robustness
  ratios and intervals to the talk's two decimals.
</commit_message>
<xml_diff>
--- a/presentations/20261116_PCSJ-IMPS2026_ポスター初案.pptx
+++ b/presentations/20261116_PCSJ-IMPS2026_ポスター初案.pptx
@@ -693,7 +693,7 @@
                   <c:v>縮小</c:v>
                 </c:pt>
                 <c:pt idx="3">
-                  <c:v>縮小＋余白</c:v>
+                  <c:v>縮小と余白</c:v>
                 </c:pt>
                 <c:pt idx="4">
                   <c:v>回転</c:v>
@@ -785,7 +785,7 @@
                   <c:v>縮小</c:v>
                 </c:pt>
                 <c:pt idx="3">
-                  <c:v>縮小＋余白</c:v>
+                  <c:v>縮小と余白</c:v>
                 </c:pt>
                 <c:pt idx="4">
                   <c:v>回転</c:v>
@@ -877,7 +877,7 @@
                   <c:v>縮小</c:v>
                 </c:pt>
                 <c:pt idx="3">
-                  <c:v>縮小＋余白</c:v>
+                  <c:v>縮小と余白</c:v>
                 </c:pt>
                 <c:pt idx="4">
                   <c:v>回転</c:v>
@@ -8188,7 +8188,7 @@
                 <a:ea typeface="游ゴシック"/>
                 <a:cs typeface="游ゴシック"/>
               </a:rPr>
-              <a:t>baseline 15.6% ／ proposal 10.0% ／ ablation 19.9%</a:t>
+              <a:t>baseline 15.65% ／ proposal 9.99% ／ ablation 19.93%</a:t>
             </a:r>
           </a:p>
           <a:p>
@@ -8222,7 +8222,7 @@
                 <a:ea typeface="游ゴシック"/>
                 <a:cs typeface="游ゴシック"/>
               </a:rPr>
-              <a:t>−9.9pt [−13.8, −6.1]</a:t>
+              <a:t>−9.95pt [−13.82, −6.07]</a:t>
             </a:r>
           </a:p>
           <a:p>
@@ -8256,7 +8256,7 @@
                 <a:ea typeface="游ゴシック"/>
                 <a:cs typeface="游ゴシック"/>
               </a:rPr>
-              <a:t>−5.7pt [−13.0, +1.7]．</a:t>
+              <a:t>−5.66pt [−13.01, +1.69]．</a:t>
             </a:r>
             <a:br>
               <a:rPr sz="2700" b="0" i="0" lang="ja-JP">

</xml_diff>

<commit_message>
docs: make both decks say exactly what was measured
Each deck left readers to guess what a term covered, and the
last edit saved them through python-pptx, which the rules forbid.
Both are rebuilt from their earlier state with text-only XML
edits.

- The three overlays are named as one family: the same white box
  holding a directive, a random string, or nothing.
- The robustness slides say which vectors are compared, that h is
  the layer-16 vector, and that layer 32 is reported but does not
  decide; the layer-32 slide is named for its two measures and
  defines an answer change.
- "整合した群" no longer covers two populations: proposal where
  one arm is meant, proposal and ablation where both are. The
  research document follows and notes that only the labels of its
  pre-registered table changed.
- The per-family caveat says why: eight intervals, one may stray.
</commit_message>
<xml_diff>
--- a/presentations/20261116_PCSJ-IMPS2026_ポスター初案.pptx
+++ b/presentations/20261116_PCSJ-IMPS2026_ポスター初案.pptx
@@ -705,7 +705,7 @@
                   <c:v>文字列</c:v>
                 </c:pt>
                 <c:pt idx="7">
-                  <c:v>白い箱</c:v>
+                  <c:v>文字なし</c:v>
                 </c:pt>
                 <c:pt idx="8">
                   <c:v>23通り</c:v>
@@ -797,7 +797,7 @@
                   <c:v>文字列</c:v>
                 </c:pt>
                 <c:pt idx="7">
-                  <c:v>白い箱</c:v>
+                  <c:v>文字なし</c:v>
                 </c:pt>
                 <c:pt idx="8">
                   <c:v>23通り</c:v>
@@ -889,7 +889,7 @@
                   <c:v>文字列</c:v>
                 </c:pt>
                 <c:pt idx="7">
-                  <c:v>白い箱</c:v>
+                  <c:v>文字なし</c:v>
                 </c:pt>
                 <c:pt idx="8">
                   <c:v>23通り</c:v>
@@ -7618,7 +7618,7 @@
                 <a:ea typeface="游ゴシック"/>
                 <a:cs typeface="游ゴシック"/>
               </a:rPr>
-              <a:t>予稿以降に測定．Wani ら[1]の加工8族23通りを全問に施し，第16層の</a:t>
+              <a:t>予稿以降に測定．Wani ら[1]の加工8族23通りを全問に施し，元の画像の第16層の</a:t>
             </a:r>
             <a:r>
               <a:rPr sz="2700" b="0" i="0" lang="ja-JP">
@@ -7640,7 +7640,7 @@
                 <a:ea typeface="游ゴシック"/>
                 <a:cs typeface="游ゴシック"/>
               </a:rPr>
-              <a:t>の動き（コサイン距離）を3群で比べた</a:t>
+              <a:t>と，加工した画像の𝒉′のコサイン距離を，同じ質問ごとに測って3群で比べた</a:t>
             </a:r>
           </a:p>
         </p:txBody>
@@ -7908,7 +7908,7 @@
                 <a:ea typeface="游ゴシック"/>
                 <a:cs typeface="游ゴシック"/>
               </a:rPr>
-              <a:t>文字の重ね書き</a:t>
+              <a:t>指示文の重ね書き</a:t>
             </a:r>
           </a:p>
         </p:txBody>
@@ -8072,7 +8072,7 @@
                 <a:ea typeface="游ゴシック"/>
                 <a:cs typeface="游ゴシック"/>
               </a:rPr>
-              <a:t>　加工前後の距離の平均 ÷ 同じ質問に別の画像を与えたときの距離の平均</a:t>
+              <a:t>　（元の画像と加工した画像の距離）の平均 ÷ （元の画像と別の画像の距離）の平均．質問は同じ</a:t>
             </a:r>
           </a:p>
         </p:txBody>
@@ -8133,7 +8133,7 @@
                 <a:ea typeface="游ゴシック"/>
                 <a:cs typeface="游ゴシック"/>
               </a:rPr>
-              <a:t>族ごとの比較は探索的（8族を3乱数種で比べている）．判定は「23通り」で行う</a:t>
+              <a:t>重ね書き3種（指示文・文字列・文字なし）は同じ白い箱で，中身だけ違う．判定は「23通り」で行う</a:t>
             </a:r>
           </a:p>
         </p:txBody>
@@ -8211,7 +8211,7 @@
                 <a:ea typeface="游ゴシック"/>
                 <a:cs typeface="游ゴシック"/>
               </a:rPr>
-              <a:t>ablation より小さい　</a:t>
+              <a:t>proposal は ablation より小さい　</a:t>
             </a:r>
             <a:r>
               <a:rPr sz="2700" b="0" i="0" lang="ja-JP">
@@ -8245,7 +8245,7 @@
                 <a:ea typeface="游ゴシック"/>
                 <a:cs typeface="游ゴシック"/>
               </a:rPr>
-              <a:t>baseline との差は向きが未決　</a:t>
+              <a:t>proposal と baseline の差は向きが未決　</a:t>
             </a:r>
             <a:r>
               <a:rPr sz="2700" b="0" i="0" lang="ja-JP">
@@ -8334,7 +8334,7 @@
                 <a:ea typeface="游ゴシック"/>
                 <a:cs typeface="游ゴシック"/>
               </a:rPr>
-              <a:t>最終層と回答では，幾何的な加工について3群の差は見られない</a:t>
+              <a:t>第32層の比と回答の変化では，幾何的な加工について3群の差は見られない</a:t>
             </a:r>
           </a:p>
         </p:txBody>
@@ -8607,7 +8607,7 @@
                 <a:ea typeface="游ゴシック"/>
                 <a:cs typeface="游ゴシック"/>
               </a:rPr>
-              <a:t>乱数種を足して安定性の向きを決める．回答の型で整合する群を足し，効果が署名に固有かを確かめる</a:t>
+              <a:t>乱数種を足して，第16層の比と距離の向きを決める．回答の型で整合する群を足し，効果が署名に固有かを確かめる</a:t>
             </a:r>
           </a:p>
           <a:p>

</xml_diff>